<commit_message>
final updates for bspace
</commit_message>
<xml_diff>
--- a/Week 11/Lab 11 Halloween AnalysisofFrequencies.pptx
+++ b/Week 11/Lab 11 Halloween AnalysisofFrequencies.pptx
@@ -5,13 +5,20 @@
     <p:sldMasterId id="2147483689" r:id="rId1"/>
   </p:sldMasterIdLst>
   <p:notesMasterIdLst>
-    <p:notesMasterId r:id="rId6"/>
+    <p:notesMasterId r:id="rId13"/>
   </p:notesMasterIdLst>
   <p:sldIdLst>
-    <p:sldId id="259" r:id="rId2"/>
-    <p:sldId id="256" r:id="rId3"/>
-    <p:sldId id="257" r:id="rId4"/>
-    <p:sldId id="258" r:id="rId5"/>
+    <p:sldId id="327" r:id="rId2"/>
+    <p:sldId id="284" r:id="rId3"/>
+    <p:sldId id="318" r:id="rId4"/>
+    <p:sldId id="319" r:id="rId5"/>
+    <p:sldId id="320" r:id="rId6"/>
+    <p:sldId id="321" r:id="rId7"/>
+    <p:sldId id="326" r:id="rId8"/>
+    <p:sldId id="324" r:id="rId9"/>
+    <p:sldId id="256" r:id="rId10"/>
+    <p:sldId id="257" r:id="rId11"/>
+    <p:sldId id="258" r:id="rId12"/>
   </p:sldIdLst>
   <p:sldSz cx="12192000" cy="6858000"/>
   <p:notesSz cx="6858000" cy="9144000"/>
@@ -115,7 +122,14 @@
       <p14:sectionLst xmlns:p14="http://schemas.microsoft.com/office/powerpoint/2010/main">
         <p14:section name="Default Section" id="{4E668BF0-029F-4430-A815-4E469E2A1ECB}">
           <p14:sldIdLst>
-            <p14:sldId id="259"/>
+            <p14:sldId id="327"/>
+            <p14:sldId id="284"/>
+            <p14:sldId id="318"/>
+            <p14:sldId id="319"/>
+            <p14:sldId id="320"/>
+            <p14:sldId id="321"/>
+            <p14:sldId id="326"/>
+            <p14:sldId id="324"/>
             <p14:sldId id="256"/>
             <p14:sldId id="257"/>
             <p14:sldId id="258"/>
@@ -136,7 +150,7 @@
 <file path=ppt/revisionInfo.xml><?xml version="1.0" encoding="utf-8"?>
 <p1510:revInfo xmlns:a="http://schemas.openxmlformats.org/drawingml/2006/main" xmlns:r="http://schemas.openxmlformats.org/officeDocument/2006/relationships" xmlns:p1510="http://schemas.microsoft.com/office/powerpoint/2015/10/main">
   <p1510:revLst>
-    <p1510:client id="{13DC3BE7-34FB-4A0C-8804-7888C6EE9A4A}" v="2" dt="2026-10-27T20:08:24.150"/>
+    <p1510:client id="{13DC3BE7-34FB-4A0C-8804-7888C6EE9A4A}" v="9" dt="2026-10-27T20:33:41.484"/>
   </p1510:revLst>
 </p1510:revInfo>
 </file>
@@ -145,8 +159,8 @@
 <pc:chgInfo xmlns:a="http://schemas.openxmlformats.org/drawingml/2006/main" xmlns:r="http://schemas.openxmlformats.org/officeDocument/2006/relationships" xmlns:ac="http://schemas.microsoft.com/office/drawing/2013/main/command" xmlns:pc="http://schemas.microsoft.com/office/powerpoint/2013/main/command">
   <pc:docChgLst>
     <pc:chgData name="Kayla Blincow" userId="ac6229071bdafc06" providerId="LiveId" clId="{9CE18A4C-68C3-4E97-A0CD-BEA78CB9776D}"/>
-    <pc:docChg chg="modSld">
-      <pc:chgData name="Kayla Blincow" userId="ac6229071bdafc06" providerId="LiveId" clId="{9CE18A4C-68C3-4E97-A0CD-BEA78CB9776D}" dt="2026-10-27T20:13:49.297" v="755" actId="20577"/>
+    <pc:docChg chg="addSld delSld modSld sldOrd modSection">
+      <pc:chgData name="Kayla Blincow" userId="ac6229071bdafc06" providerId="LiveId" clId="{9CE18A4C-68C3-4E97-A0CD-BEA78CB9776D}" dt="2026-10-27T20:40:59.934" v="928" actId="20577"/>
       <pc:docMkLst>
         <pc:docMk/>
       </pc:docMkLst>
@@ -162,6 +176,99 @@
         <pc:sldMkLst>
           <pc:docMk/>
           <pc:sldMk cId="157032003" sldId="257"/>
+        </pc:sldMkLst>
+      </pc:sldChg>
+      <pc:sldChg chg="del">
+        <pc:chgData name="Kayla Blincow" userId="ac6229071bdafc06" providerId="LiveId" clId="{9CE18A4C-68C3-4E97-A0CD-BEA78CB9776D}" dt="2026-10-27T20:33:25.323" v="764" actId="47"/>
+        <pc:sldMkLst>
+          <pc:docMk/>
+          <pc:sldMk cId="2600757249" sldId="259"/>
+        </pc:sldMkLst>
+      </pc:sldChg>
+      <pc:sldChg chg="modSp add mod ord">
+        <pc:chgData name="Kayla Blincow" userId="ac6229071bdafc06" providerId="LiveId" clId="{9CE18A4C-68C3-4E97-A0CD-BEA78CB9776D}" dt="2026-10-27T20:40:59.934" v="928" actId="20577"/>
+        <pc:sldMkLst>
+          <pc:docMk/>
+          <pc:sldMk cId="949666939" sldId="284"/>
+        </pc:sldMkLst>
+        <pc:spChg chg="mod">
+          <ac:chgData name="Kayla Blincow" userId="ac6229071bdafc06" providerId="LiveId" clId="{9CE18A4C-68C3-4E97-A0CD-BEA78CB9776D}" dt="2026-10-27T20:40:59.934" v="928" actId="20577"/>
+          <ac:spMkLst>
+            <pc:docMk/>
+            <pc:sldMk cId="949666939" sldId="284"/>
+            <ac:spMk id="3" creationId="{5EC916F8-2617-0B7F-D699-7AE508E9AD38}"/>
+          </ac:spMkLst>
+        </pc:spChg>
+      </pc:sldChg>
+      <pc:sldChg chg="add">
+        <pc:chgData name="Kayla Blincow" userId="ac6229071bdafc06" providerId="LiveId" clId="{9CE18A4C-68C3-4E97-A0CD-BEA78CB9776D}" dt="2026-10-27T20:32:23.307" v="762"/>
+        <pc:sldMkLst>
+          <pc:docMk/>
+          <pc:sldMk cId="3207386173" sldId="318"/>
+        </pc:sldMkLst>
+      </pc:sldChg>
+      <pc:sldChg chg="add">
+        <pc:chgData name="Kayla Blincow" userId="ac6229071bdafc06" providerId="LiveId" clId="{9CE18A4C-68C3-4E97-A0CD-BEA78CB9776D}" dt="2026-10-27T20:32:38.482" v="763"/>
+        <pc:sldMkLst>
+          <pc:docMk/>
+          <pc:sldMk cId="1938947169" sldId="319"/>
+        </pc:sldMkLst>
+      </pc:sldChg>
+      <pc:sldChg chg="add">
+        <pc:chgData name="Kayla Blincow" userId="ac6229071bdafc06" providerId="LiveId" clId="{9CE18A4C-68C3-4E97-A0CD-BEA78CB9776D}" dt="2026-10-27T20:32:38.482" v="763"/>
+        <pc:sldMkLst>
+          <pc:docMk/>
+          <pc:sldMk cId="285636063" sldId="320"/>
+        </pc:sldMkLst>
+      </pc:sldChg>
+      <pc:sldChg chg="add">
+        <pc:chgData name="Kayla Blincow" userId="ac6229071bdafc06" providerId="LiveId" clId="{9CE18A4C-68C3-4E97-A0CD-BEA78CB9776D}" dt="2026-10-27T20:31:34.929" v="756"/>
+        <pc:sldMkLst>
+          <pc:docMk/>
+          <pc:sldMk cId="2160442981" sldId="321"/>
+        </pc:sldMkLst>
+      </pc:sldChg>
+      <pc:sldChg chg="add ord">
+        <pc:chgData name="Kayla Blincow" userId="ac6229071bdafc06" providerId="LiveId" clId="{9CE18A4C-68C3-4E97-A0CD-BEA78CB9776D}" dt="2026-10-27T20:31:56.273" v="759"/>
+        <pc:sldMkLst>
+          <pc:docMk/>
+          <pc:sldMk cId="2578597199" sldId="324"/>
+        </pc:sldMkLst>
+      </pc:sldChg>
+      <pc:sldChg chg="add ord">
+        <pc:chgData name="Kayla Blincow" userId="ac6229071bdafc06" providerId="LiveId" clId="{9CE18A4C-68C3-4E97-A0CD-BEA78CB9776D}" dt="2026-10-27T20:31:59.121" v="761"/>
+        <pc:sldMkLst>
+          <pc:docMk/>
+          <pc:sldMk cId="4170928680" sldId="326"/>
+        </pc:sldMkLst>
+      </pc:sldChg>
+      <pc:sldChg chg="modSp add mod ord">
+        <pc:chgData name="Kayla Blincow" userId="ac6229071bdafc06" providerId="LiveId" clId="{9CE18A4C-68C3-4E97-A0CD-BEA78CB9776D}" dt="2026-10-27T20:33:55.616" v="771" actId="20577"/>
+        <pc:sldMkLst>
+          <pc:docMk/>
+          <pc:sldMk cId="2948685846" sldId="327"/>
+        </pc:sldMkLst>
+        <pc:spChg chg="mod">
+          <ac:chgData name="Kayla Blincow" userId="ac6229071bdafc06" providerId="LiveId" clId="{9CE18A4C-68C3-4E97-A0CD-BEA78CB9776D}" dt="2026-10-27T20:33:55.616" v="771" actId="20577"/>
+          <ac:spMkLst>
+            <pc:docMk/>
+            <pc:sldMk cId="2948685846" sldId="327"/>
+            <ac:spMk id="2" creationId="{D24B8A19-FA22-C682-4310-EEAA4459904E}"/>
+          </ac:spMkLst>
+        </pc:spChg>
+      </pc:sldChg>
+      <pc:sldChg chg="add del">
+        <pc:chgData name="Kayla Blincow" userId="ac6229071bdafc06" providerId="LiveId" clId="{9CE18A4C-68C3-4E97-A0CD-BEA78CB9776D}" dt="2026-10-27T20:33:29.026" v="766"/>
+        <pc:sldMkLst>
+          <pc:docMk/>
+          <pc:sldMk cId="3678275170" sldId="327"/>
+        </pc:sldMkLst>
+      </pc:sldChg>
+      <pc:sldChg chg="add del">
+        <pc:chgData name="Kayla Blincow" userId="ac6229071bdafc06" providerId="LiveId" clId="{9CE18A4C-68C3-4E97-A0CD-BEA78CB9776D}" dt="2026-10-27T20:33:29.026" v="766"/>
+        <pc:sldMkLst>
+          <pc:docMk/>
+          <pc:sldMk cId="973742649" sldId="328"/>
         </pc:sldMkLst>
       </pc:sldChg>
     </pc:docChg>
@@ -562,9 +669,6 @@
           <a:bodyPr/>
           <a:lstStyle/>
           <a:p>
-            <a:br>
-              <a:rPr lang="en-US" dirty="0"/>
-            </a:br>
             <a:endParaRPr lang="en-US" dirty="0"/>
           </a:p>
         </p:txBody>
@@ -584,9 +688,9 @@
           <a:bodyPr/>
           <a:lstStyle/>
           <a:p>
-            <a:fld id="{350AB6E2-3D28-450E-9825-49CD3769091C}" type="slidenum">
+            <a:fld id="{B532F4B8-4792-4BBE-9010-0D4D9882B9B9}" type="slidenum">
               <a:rPr lang="en-US" smtClean="0"/>
-              <a:t>2</a:t>
+              <a:t>1</a:t>
             </a:fld>
             <a:endParaRPr lang="en-US"/>
           </a:p>
@@ -595,7 +699,7 @@
     </p:spTree>
     <p:extLst>
       <p:ext uri="{BB962C8B-B14F-4D97-AF65-F5344CB8AC3E}">
-        <p14:creationId xmlns:p14="http://schemas.microsoft.com/office/powerpoint/2010/main" val="3985232349"/>
+        <p14:creationId xmlns:p14="http://schemas.microsoft.com/office/powerpoint/2010/main" val="3643247056"/>
       </p:ext>
     </p:extLst>
   </p:cSld>
@@ -649,6 +753,93 @@
           <a:bodyPr/>
           <a:lstStyle/>
           <a:p>
+            <a:br>
+              <a:rPr lang="en-US" dirty="0"/>
+            </a:br>
+            <a:endParaRPr lang="en-US" dirty="0"/>
+          </a:p>
+        </p:txBody>
+      </p:sp>
+      <p:sp>
+        <p:nvSpPr>
+          <p:cNvPr id="4" name="Slide Number Placeholder 3"/>
+          <p:cNvSpPr>
+            <a:spLocks noGrp="1"/>
+          </p:cNvSpPr>
+          <p:nvPr>
+            <p:ph type="sldNum" sz="quarter" idx="5"/>
+          </p:nvPr>
+        </p:nvSpPr>
+        <p:spPr/>
+        <p:txBody>
+          <a:bodyPr/>
+          <a:lstStyle/>
+          <a:p>
+            <a:fld id="{350AB6E2-3D28-450E-9825-49CD3769091C}" type="slidenum">
+              <a:rPr lang="en-US" smtClean="0"/>
+              <a:t>9</a:t>
+            </a:fld>
+            <a:endParaRPr lang="en-US"/>
+          </a:p>
+        </p:txBody>
+      </p:sp>
+    </p:spTree>
+    <p:extLst>
+      <p:ext uri="{BB962C8B-B14F-4D97-AF65-F5344CB8AC3E}">
+        <p14:creationId xmlns:p14="http://schemas.microsoft.com/office/powerpoint/2010/main" val="3985232349"/>
+      </p:ext>
+    </p:extLst>
+  </p:cSld>
+  <p:clrMapOvr>
+    <a:masterClrMapping/>
+  </p:clrMapOvr>
+</p:notes>
+</file>
+
+<file path=ppt/notesSlides/notesSlide3.xml><?xml version="1.0" encoding="utf-8"?>
+<p:notes xmlns:a="http://schemas.openxmlformats.org/drawingml/2006/main" xmlns:r="http://schemas.openxmlformats.org/officeDocument/2006/relationships" xmlns:p="http://schemas.openxmlformats.org/presentationml/2006/main">
+  <p:cSld>
+    <p:spTree>
+      <p:nvGrpSpPr>
+        <p:cNvPr id="1" name=""/>
+        <p:cNvGrpSpPr/>
+        <p:nvPr/>
+      </p:nvGrpSpPr>
+      <p:grpSpPr>
+        <a:xfrm>
+          <a:off x="0" y="0"/>
+          <a:ext cx="0" cy="0"/>
+          <a:chOff x="0" y="0"/>
+          <a:chExt cx="0" cy="0"/>
+        </a:xfrm>
+      </p:grpSpPr>
+      <p:sp>
+        <p:nvSpPr>
+          <p:cNvPr id="2" name="Slide Image Placeholder 1"/>
+          <p:cNvSpPr>
+            <a:spLocks noGrp="1" noRot="1" noChangeAspect="1"/>
+          </p:cNvSpPr>
+          <p:nvPr>
+            <p:ph type="sldImg"/>
+          </p:nvPr>
+        </p:nvSpPr>
+        <p:spPr/>
+      </p:sp>
+      <p:sp>
+        <p:nvSpPr>
+          <p:cNvPr id="3" name="Notes Placeholder 2"/>
+          <p:cNvSpPr>
+            <a:spLocks noGrp="1"/>
+          </p:cNvSpPr>
+          <p:nvPr>
+            <p:ph type="body" idx="1"/>
+          </p:nvPr>
+        </p:nvSpPr>
+        <p:spPr/>
+        <p:txBody>
+          <a:bodyPr/>
+          <a:lstStyle/>
+          <a:p>
             <a:pPr rtl="0"/>
             <a:r>
               <a:rPr lang="en-US" sz="1200" b="0" i="0" u="none" strike="noStrike" kern="1200" dirty="0">
@@ -768,19 +959,7 @@
                 <a:ea typeface="+mn-ea"/>
                 <a:cs typeface="+mn-cs"/>
               </a:rPr>
-              <a:t>The authorities found no clear evidence of what had happened to Dr. Wren. With no heirs willing to maintain the property, the manor was boarded up. Over the decades, rumors grew. Townspeople reported seeing strange lights behind the boarded windows and hearing inexplicable noises from within. Those unlucky enough to be dared to go inside during childhood games of truth or dare, swear that they saw the ghost of Dr. Wren pacing his laboratory… Is he protecting his secrets? Or waiting for someone </a:t>
-            </a:r>
-            <a:r>
-              <a:rPr lang="en-US" sz="1200" b="0" i="0" u="none" strike="noStrike" kern="1200">
-                <a:solidFill>
-                  <a:schemeClr val="tx1"/>
-                </a:solidFill>
-                <a:effectLst/>
-                <a:latin typeface="+mn-lt"/>
-                <a:ea typeface="+mn-ea"/>
-                <a:cs typeface="+mn-cs"/>
-              </a:rPr>
-              <a:t>to uncover them?</a:t>
+              <a:t>The authorities found no clear evidence of what had happened to Dr. Wren. With no heirs willing to maintain the property, the manor was boarded up. Over the decades, rumors grew. Townspeople reported seeing strange lights behind the boarded windows and hearing inexplicable noises from within. Those unlucky enough to be dared to go inside during childhood games of truth or dare, swear that they saw the ghost of Dr. Wren pacing his laboratory… Is he protecting his secrets? Or waiting for someone to uncover them?</a:t>
             </a:r>
             <a:endParaRPr lang="en-US" b="0" dirty="0">
               <a:effectLst/>
@@ -841,7 +1020,7 @@
           <a:p>
             <a:fld id="{350AB6E2-3D28-450E-9825-49CD3769091C}" type="slidenum">
               <a:rPr lang="en-US" smtClean="0"/>
-              <a:t>3</a:t>
+              <a:t>10</a:t>
             </a:fld>
             <a:endParaRPr lang="en-US"/>
           </a:p>
@@ -4084,55 +4263,469 @@
           <p:cNvPr id="2" name="Title 1">
             <a:extLst>
               <a:ext uri="{FF2B5EF4-FFF2-40B4-BE49-F238E27FC236}">
-                <a16:creationId xmlns:a16="http://schemas.microsoft.com/office/drawing/2014/main" id="{4DE17D0C-5CAB-1265-85C8-DF318309F6AC}"/>
-              </a:ext>
-            </a:extLst>
-          </p:cNvPr>
-          <p:cNvSpPr>
-            <a:spLocks noGrp="1"/>
-          </p:cNvSpPr>
-          <p:nvPr>
-            <p:ph type="title"/>
-          </p:nvPr>
-        </p:nvSpPr>
-        <p:spPr/>
-        <p:txBody>
-          <a:bodyPr/>
-          <a:lstStyle/>
-          <a:p>
-            <a:endParaRPr lang="en-US"/>
-          </a:p>
-        </p:txBody>
-      </p:sp>
-      <p:sp>
-        <p:nvSpPr>
-          <p:cNvPr id="3" name="Content Placeholder 2">
-            <a:extLst>
-              <a:ext uri="{FF2B5EF4-FFF2-40B4-BE49-F238E27FC236}">
-                <a16:creationId xmlns:a16="http://schemas.microsoft.com/office/drawing/2014/main" id="{1BC5F64D-BBCD-640E-3D8C-40871199E41E}"/>
-              </a:ext>
-            </a:extLst>
-          </p:cNvPr>
-          <p:cNvSpPr>
-            <a:spLocks noGrp="1"/>
-          </p:cNvSpPr>
-          <p:nvPr>
-            <p:ph idx="1"/>
-          </p:nvPr>
-        </p:nvSpPr>
-        <p:spPr/>
-        <p:txBody>
-          <a:bodyPr/>
-          <a:lstStyle/>
-          <a:p>
-            <a:endParaRPr lang="en-US"/>
-          </a:p>
-        </p:txBody>
-      </p:sp>
+                <a16:creationId xmlns:a16="http://schemas.microsoft.com/office/drawing/2014/main" id="{D24B8A19-FA22-C682-4310-EEAA4459904E}"/>
+              </a:ext>
+            </a:extLst>
+          </p:cNvPr>
+          <p:cNvSpPr>
+            <a:spLocks noGrp="1"/>
+          </p:cNvSpPr>
+          <p:nvPr>
+            <p:ph type="ctrTitle"/>
+          </p:nvPr>
+        </p:nvSpPr>
+        <p:spPr>
+          <a:xfrm>
+            <a:off x="4812630" y="1600200"/>
+            <a:ext cx="5855368" cy="1801311"/>
+          </a:xfrm>
+        </p:spPr>
+        <p:txBody>
+          <a:bodyPr/>
+          <a:lstStyle/>
+          <a:p>
+            <a:r>
+              <a:rPr lang="en-US" dirty="0"/>
+              <a:t>MES 503 Lab 11</a:t>
+            </a:r>
+          </a:p>
+        </p:txBody>
+      </p:sp>
+      <p:sp>
+        <p:nvSpPr>
+          <p:cNvPr id="3" name="Subtitle 2">
+            <a:extLst>
+              <a:ext uri="{FF2B5EF4-FFF2-40B4-BE49-F238E27FC236}">
+                <a16:creationId xmlns:a16="http://schemas.microsoft.com/office/drawing/2014/main" id="{F07B767E-3D5A-B7E7-2441-4EBD66E2A63F}"/>
+              </a:ext>
+            </a:extLst>
+          </p:cNvPr>
+          <p:cNvSpPr>
+            <a:spLocks noGrp="1"/>
+          </p:cNvSpPr>
+          <p:nvPr>
+            <p:ph type="subTitle" idx="1"/>
+          </p:nvPr>
+        </p:nvSpPr>
+        <p:spPr>
+          <a:xfrm>
+            <a:off x="4812630" y="3602038"/>
+            <a:ext cx="5855369" cy="1655762"/>
+          </a:xfrm>
+        </p:spPr>
+        <p:txBody>
+          <a:bodyPr/>
+          <a:lstStyle/>
+          <a:p>
+            <a:r>
+              <a:rPr lang="en-US" dirty="0"/>
+              <a:t>Kayla Blincow, PhD</a:t>
+            </a:r>
+          </a:p>
+        </p:txBody>
+      </p:sp>
+      <p:pic>
+        <p:nvPicPr>
+          <p:cNvPr id="4" name="Picture 2" descr="R Memes for Statistical Fiends on Twitter: &quot;More R memes created directly  in R with @thosjleeper package &quot;memes&quot; https://t.co/R6MNt7sSzV #rstats… &quot;">
+            <a:extLst>
+              <a:ext uri="{FF2B5EF4-FFF2-40B4-BE49-F238E27FC236}">
+                <a16:creationId xmlns:a16="http://schemas.microsoft.com/office/drawing/2014/main" id="{4E2F905E-C631-73E1-AB39-F358E6C87B15}"/>
+              </a:ext>
+            </a:extLst>
+          </p:cNvPr>
+          <p:cNvPicPr>
+            <a:picLocks noChangeAspect="1" noChangeArrowheads="1"/>
+          </p:cNvPicPr>
+          <p:nvPr/>
+        </p:nvPicPr>
+        <p:blipFill>
+          <a:blip r:embed="rId3" cstate="print">
+            <a:extLst>
+              <a:ext uri="{28A0092B-C50C-407E-A947-70E740481C1C}">
+                <a14:useLocalDpi xmlns:a14="http://schemas.microsoft.com/office/drawing/2010/main" val="0"/>
+              </a:ext>
+            </a:extLst>
+          </a:blip>
+          <a:srcRect/>
+          <a:stretch>
+            <a:fillRect/>
+          </a:stretch>
+        </p:blipFill>
+        <p:spPr bwMode="auto">
+          <a:xfrm>
+            <a:off x="930443" y="1250651"/>
+            <a:ext cx="3449053" cy="4356698"/>
+          </a:xfrm>
+          <a:prstGeom prst="rect">
+            <a:avLst/>
+          </a:prstGeom>
+          <a:noFill/>
+          <a:extLst>
+            <a:ext uri="{909E8E84-426E-40DD-AFC4-6F175D3DCCD1}">
+              <a14:hiddenFill xmlns:a14="http://schemas.microsoft.com/office/drawing/2010/main">
+                <a:solidFill>
+                  <a:srgbClr val="FFFFFF"/>
+                </a:solidFill>
+              </a14:hiddenFill>
+            </a:ext>
+          </a:extLst>
+        </p:spPr>
+      </p:pic>
     </p:spTree>
     <p:extLst>
       <p:ext uri="{BB962C8B-B14F-4D97-AF65-F5344CB8AC3E}">
-        <p14:creationId xmlns:p14="http://schemas.microsoft.com/office/powerpoint/2010/main" val="2600757249"/>
+        <p14:creationId xmlns:p14="http://schemas.microsoft.com/office/powerpoint/2010/main" val="2948685846"/>
+      </p:ext>
+    </p:extLst>
+  </p:cSld>
+  <p:clrMapOvr>
+    <a:masterClrMapping/>
+  </p:clrMapOvr>
+</p:sld>
+</file>
+
+<file path=ppt/slides/slide10.xml><?xml version="1.0" encoding="utf-8"?>
+<p:sld xmlns:a="http://schemas.openxmlformats.org/drawingml/2006/main" xmlns:r="http://schemas.openxmlformats.org/officeDocument/2006/relationships" xmlns:p="http://schemas.openxmlformats.org/presentationml/2006/main">
+  <p:cSld>
+    <p:spTree>
+      <p:nvGrpSpPr>
+        <p:cNvPr id="1" name=""/>
+        <p:cNvGrpSpPr/>
+        <p:nvPr/>
+      </p:nvGrpSpPr>
+      <p:grpSpPr>
+        <a:xfrm>
+          <a:off x="0" y="0"/>
+          <a:ext cx="0" cy="0"/>
+          <a:chOff x="0" y="0"/>
+          <a:chExt cx="0" cy="0"/>
+        </a:xfrm>
+      </p:grpSpPr>
+      <p:pic>
+        <p:nvPicPr>
+          <p:cNvPr id="4" name="Picture 3" descr="The Haunting of Crimson Manor (Horror Romance) - LifeShouts.com">
+            <a:extLst>
+              <a:ext uri="{FF2B5EF4-FFF2-40B4-BE49-F238E27FC236}">
+                <a16:creationId xmlns:a16="http://schemas.microsoft.com/office/drawing/2014/main" id="{60621E70-F632-66D5-EFA9-0A8CE0F7E53A}"/>
+              </a:ext>
+            </a:extLst>
+          </p:cNvPr>
+          <p:cNvPicPr>
+            <a:picLocks noChangeAspect="1"/>
+          </p:cNvPicPr>
+          <p:nvPr/>
+        </p:nvPicPr>
+        <p:blipFill>
+          <a:blip r:embed="rId3"/>
+          <a:stretch>
+            <a:fillRect/>
+          </a:stretch>
+        </p:blipFill>
+        <p:spPr>
+          <a:xfrm>
+            <a:off x="892628" y="459609"/>
+            <a:ext cx="10406743" cy="5938782"/>
+          </a:xfrm>
+          <a:prstGeom prst="rect">
+            <a:avLst/>
+          </a:prstGeom>
+        </p:spPr>
+      </p:pic>
+      <p:sp>
+        <p:nvSpPr>
+          <p:cNvPr id="5" name="Content Placeholder 2">
+            <a:extLst>
+              <a:ext uri="{FF2B5EF4-FFF2-40B4-BE49-F238E27FC236}">
+                <a16:creationId xmlns:a16="http://schemas.microsoft.com/office/drawing/2014/main" id="{CFFF9CA3-3824-81D0-5D75-5B50DC9CB6A0}"/>
+              </a:ext>
+            </a:extLst>
+          </p:cNvPr>
+          <p:cNvSpPr txBox="1">
+            <a:spLocks/>
+          </p:cNvSpPr>
+          <p:nvPr/>
+        </p:nvSpPr>
+        <p:spPr>
+          <a:xfrm>
+            <a:off x="-745672" y="6539139"/>
+            <a:ext cx="13683342" cy="318861"/>
+          </a:xfrm>
+          <a:prstGeom prst="rect">
+            <a:avLst/>
+          </a:prstGeom>
+        </p:spPr>
+        <p:txBody>
+          <a:bodyPr vert="horz" lIns="91440" tIns="45720" rIns="91440" bIns="45720" rtlCol="0">
+            <a:normAutofit fontScale="77500" lnSpcReduction="20000"/>
+          </a:bodyPr>
+          <a:lstStyle>
+            <a:lvl1pPr marL="0" indent="0" algn="ctr" defTabSz="914400" rtl="0" eaLnBrk="1" latinLnBrk="0" hangingPunct="1">
+              <a:lnSpc>
+                <a:spcPct val="90000"/>
+              </a:lnSpc>
+              <a:spcBef>
+                <a:spcPts val="1000"/>
+              </a:spcBef>
+              <a:buFont typeface="Arial" panose="020B0604020202020204" pitchFamily="34" charset="0"/>
+              <a:buNone/>
+              <a:defRPr sz="2400" kern="1200">
+                <a:solidFill>
+                  <a:schemeClr val="tx1"/>
+                </a:solidFill>
+                <a:latin typeface="+mn-lt"/>
+                <a:ea typeface="+mn-ea"/>
+                <a:cs typeface="+mn-cs"/>
+              </a:defRPr>
+            </a:lvl1pPr>
+            <a:lvl2pPr marL="457200" indent="0" algn="ctr" defTabSz="914400" rtl="0" eaLnBrk="1" latinLnBrk="0" hangingPunct="1">
+              <a:lnSpc>
+                <a:spcPct val="90000"/>
+              </a:lnSpc>
+              <a:spcBef>
+                <a:spcPts val="500"/>
+              </a:spcBef>
+              <a:buFont typeface="Arial" panose="020B0604020202020204" pitchFamily="34" charset="0"/>
+              <a:buNone/>
+              <a:defRPr sz="2000" kern="1200">
+                <a:solidFill>
+                  <a:schemeClr val="tx1"/>
+                </a:solidFill>
+                <a:latin typeface="+mn-lt"/>
+                <a:ea typeface="+mn-ea"/>
+                <a:cs typeface="+mn-cs"/>
+              </a:defRPr>
+            </a:lvl2pPr>
+            <a:lvl3pPr marL="914400" indent="0" algn="ctr" defTabSz="914400" rtl="0" eaLnBrk="1" latinLnBrk="0" hangingPunct="1">
+              <a:lnSpc>
+                <a:spcPct val="90000"/>
+              </a:lnSpc>
+              <a:spcBef>
+                <a:spcPts val="500"/>
+              </a:spcBef>
+              <a:buFont typeface="Arial" panose="020B0604020202020204" pitchFamily="34" charset="0"/>
+              <a:buNone/>
+              <a:defRPr sz="1800" kern="1200">
+                <a:solidFill>
+                  <a:schemeClr val="tx1"/>
+                </a:solidFill>
+                <a:latin typeface="+mn-lt"/>
+                <a:ea typeface="+mn-ea"/>
+                <a:cs typeface="+mn-cs"/>
+              </a:defRPr>
+            </a:lvl3pPr>
+            <a:lvl4pPr marL="1371600" indent="0" algn="ctr" defTabSz="914400" rtl="0" eaLnBrk="1" latinLnBrk="0" hangingPunct="1">
+              <a:lnSpc>
+                <a:spcPct val="90000"/>
+              </a:lnSpc>
+              <a:spcBef>
+                <a:spcPts val="500"/>
+              </a:spcBef>
+              <a:buFont typeface="Arial" panose="020B0604020202020204" pitchFamily="34" charset="0"/>
+              <a:buNone/>
+              <a:defRPr sz="1600" kern="1200">
+                <a:solidFill>
+                  <a:schemeClr val="tx1"/>
+                </a:solidFill>
+                <a:latin typeface="+mn-lt"/>
+                <a:ea typeface="+mn-ea"/>
+                <a:cs typeface="+mn-cs"/>
+              </a:defRPr>
+            </a:lvl4pPr>
+            <a:lvl5pPr marL="1828800" indent="0" algn="ctr" defTabSz="914400" rtl="0" eaLnBrk="1" latinLnBrk="0" hangingPunct="1">
+              <a:lnSpc>
+                <a:spcPct val="90000"/>
+              </a:lnSpc>
+              <a:spcBef>
+                <a:spcPts val="500"/>
+              </a:spcBef>
+              <a:buFont typeface="Arial" panose="020B0604020202020204" pitchFamily="34" charset="0"/>
+              <a:buNone/>
+              <a:defRPr sz="1600" kern="1200">
+                <a:solidFill>
+                  <a:schemeClr val="tx1"/>
+                </a:solidFill>
+                <a:latin typeface="+mn-lt"/>
+                <a:ea typeface="+mn-ea"/>
+                <a:cs typeface="+mn-cs"/>
+              </a:defRPr>
+            </a:lvl5pPr>
+            <a:lvl6pPr marL="2286000" indent="0" algn="ctr" defTabSz="914400" rtl="0" eaLnBrk="1" latinLnBrk="0" hangingPunct="1">
+              <a:lnSpc>
+                <a:spcPct val="90000"/>
+              </a:lnSpc>
+              <a:spcBef>
+                <a:spcPts val="500"/>
+              </a:spcBef>
+              <a:buFont typeface="Arial" panose="020B0604020202020204" pitchFamily="34" charset="0"/>
+              <a:buNone/>
+              <a:defRPr sz="1600" kern="1200">
+                <a:solidFill>
+                  <a:schemeClr val="tx1"/>
+                </a:solidFill>
+                <a:latin typeface="+mn-lt"/>
+                <a:ea typeface="+mn-ea"/>
+                <a:cs typeface="+mn-cs"/>
+              </a:defRPr>
+            </a:lvl6pPr>
+            <a:lvl7pPr marL="2743200" indent="0" algn="ctr" defTabSz="914400" rtl="0" eaLnBrk="1" latinLnBrk="0" hangingPunct="1">
+              <a:lnSpc>
+                <a:spcPct val="90000"/>
+              </a:lnSpc>
+              <a:spcBef>
+                <a:spcPts val="500"/>
+              </a:spcBef>
+              <a:buFont typeface="Arial" panose="020B0604020202020204" pitchFamily="34" charset="0"/>
+              <a:buNone/>
+              <a:defRPr sz="1600" kern="1200">
+                <a:solidFill>
+                  <a:schemeClr val="tx1"/>
+                </a:solidFill>
+                <a:latin typeface="+mn-lt"/>
+                <a:ea typeface="+mn-ea"/>
+                <a:cs typeface="+mn-cs"/>
+              </a:defRPr>
+            </a:lvl7pPr>
+            <a:lvl8pPr marL="3200400" indent="0" algn="ctr" defTabSz="914400" rtl="0" eaLnBrk="1" latinLnBrk="0" hangingPunct="1">
+              <a:lnSpc>
+                <a:spcPct val="90000"/>
+              </a:lnSpc>
+              <a:spcBef>
+                <a:spcPts val="500"/>
+              </a:spcBef>
+              <a:buFont typeface="Arial" panose="020B0604020202020204" pitchFamily="34" charset="0"/>
+              <a:buNone/>
+              <a:defRPr sz="1600" kern="1200">
+                <a:solidFill>
+                  <a:schemeClr val="tx1"/>
+                </a:solidFill>
+                <a:latin typeface="+mn-lt"/>
+                <a:ea typeface="+mn-ea"/>
+                <a:cs typeface="+mn-cs"/>
+              </a:defRPr>
+            </a:lvl8pPr>
+            <a:lvl9pPr marL="3657600" indent="0" algn="ctr" defTabSz="914400" rtl="0" eaLnBrk="1" latinLnBrk="0" hangingPunct="1">
+              <a:lnSpc>
+                <a:spcPct val="90000"/>
+              </a:lnSpc>
+              <a:spcBef>
+                <a:spcPts val="500"/>
+              </a:spcBef>
+              <a:buFont typeface="Arial" panose="020B0604020202020204" pitchFamily="34" charset="0"/>
+              <a:buNone/>
+              <a:defRPr sz="1600" kern="1200">
+                <a:solidFill>
+                  <a:schemeClr val="tx1"/>
+                </a:solidFill>
+                <a:latin typeface="+mn-lt"/>
+                <a:ea typeface="+mn-ea"/>
+                <a:cs typeface="+mn-cs"/>
+              </a:defRPr>
+            </a:lvl9pPr>
+          </a:lstStyle>
+          <a:p>
+            <a:r>
+              <a:rPr lang="en-US" dirty="0">
+                <a:hlinkClick r:id="rId4">
+                  <a:extLst>
+                    <a:ext uri="{A12FA001-AC4F-418D-AE19-62706E023703}">
+                      <ahyp:hlinkClr xmlns:ahyp="http://schemas.microsoft.com/office/drawing/2018/hyperlinkcolor" val="tx"/>
+                    </a:ext>
+                  </a:extLst>
+                </a:hlinkClick>
+              </a:rPr>
+              <a:t>https://kmblincow-the-blackwater-manor-incident.share.connect.posit.cloud/</a:t>
+            </a:r>
+            <a:r>
+              <a:rPr lang="en-US" dirty="0"/>
+              <a:t> </a:t>
+            </a:r>
+          </a:p>
+        </p:txBody>
+      </p:sp>
+    </p:spTree>
+    <p:extLst>
+      <p:ext uri="{BB962C8B-B14F-4D97-AF65-F5344CB8AC3E}">
+        <p14:creationId xmlns:p14="http://schemas.microsoft.com/office/powerpoint/2010/main" val="157032003"/>
+      </p:ext>
+    </p:extLst>
+  </p:cSld>
+  <p:clrMapOvr>
+    <a:masterClrMapping/>
+  </p:clrMapOvr>
+</p:sld>
+</file>
+
+<file path=ppt/slides/slide11.xml><?xml version="1.0" encoding="utf-8"?>
+<p:sld xmlns:a="http://schemas.openxmlformats.org/drawingml/2006/main" xmlns:r="http://schemas.openxmlformats.org/officeDocument/2006/relationships" xmlns:p="http://schemas.openxmlformats.org/presentationml/2006/main">
+  <p:cSld>
+    <p:spTree>
+      <p:nvGrpSpPr>
+        <p:cNvPr id="1" name=""/>
+        <p:cNvGrpSpPr/>
+        <p:nvPr/>
+      </p:nvGrpSpPr>
+      <p:grpSpPr>
+        <a:xfrm>
+          <a:off x="0" y="0"/>
+          <a:ext cx="0" cy="0"/>
+          <a:chOff x="0" y="0"/>
+          <a:chExt cx="0" cy="0"/>
+        </a:xfrm>
+      </p:grpSpPr>
+      <p:sp>
+        <p:nvSpPr>
+          <p:cNvPr id="2" name="Title 1">
+            <a:extLst>
+              <a:ext uri="{FF2B5EF4-FFF2-40B4-BE49-F238E27FC236}">
+                <a16:creationId xmlns:a16="http://schemas.microsoft.com/office/drawing/2014/main" id="{67A4400D-801D-55F5-D2BB-237C15C3BE05}"/>
+              </a:ext>
+            </a:extLst>
+          </p:cNvPr>
+          <p:cNvSpPr>
+            <a:spLocks noGrp="1"/>
+          </p:cNvSpPr>
+          <p:nvPr>
+            <p:ph type="title"/>
+          </p:nvPr>
+        </p:nvSpPr>
+        <p:spPr/>
+        <p:txBody>
+          <a:bodyPr/>
+          <a:lstStyle/>
+          <a:p>
+            <a:endParaRPr lang="en-US" dirty="0"/>
+          </a:p>
+        </p:txBody>
+      </p:sp>
+      <p:sp>
+        <p:nvSpPr>
+          <p:cNvPr id="5" name="Content Placeholder 4">
+            <a:extLst>
+              <a:ext uri="{FF2B5EF4-FFF2-40B4-BE49-F238E27FC236}">
+                <a16:creationId xmlns:a16="http://schemas.microsoft.com/office/drawing/2014/main" id="{D0170FCA-CA42-4394-418A-F0C78792291E}"/>
+              </a:ext>
+            </a:extLst>
+          </p:cNvPr>
+          <p:cNvSpPr>
+            <a:spLocks noGrp="1"/>
+          </p:cNvSpPr>
+          <p:nvPr>
+            <p:ph idx="1"/>
+          </p:nvPr>
+        </p:nvSpPr>
+        <p:spPr/>
+        <p:txBody>
+          <a:bodyPr/>
+          <a:lstStyle/>
+          <a:p>
+            <a:endParaRPr lang="en-US"/>
+          </a:p>
+        </p:txBody>
+      </p:sp>
+    </p:spTree>
+    <p:extLst>
+      <p:ext uri="{BB962C8B-B14F-4D97-AF65-F5344CB8AC3E}">
+        <p14:creationId xmlns:p14="http://schemas.microsoft.com/office/powerpoint/2010/main" val="386430998"/>
       </p:ext>
     </p:extLst>
   </p:cSld>
@@ -4164,15 +4757,15 @@
           <p:cNvPr id="2" name="Title 1">
             <a:extLst>
               <a:ext uri="{FF2B5EF4-FFF2-40B4-BE49-F238E27FC236}">
-                <a16:creationId xmlns:a16="http://schemas.microsoft.com/office/drawing/2014/main" id="{90C8D978-FD48-DCA3-7823-51CCDA0D4E92}"/>
-              </a:ext>
-            </a:extLst>
-          </p:cNvPr>
-          <p:cNvSpPr>
-            <a:spLocks noGrp="1"/>
-          </p:cNvSpPr>
-          <p:nvPr>
-            <p:ph type="ctrTitle"/>
+                <a16:creationId xmlns:a16="http://schemas.microsoft.com/office/drawing/2014/main" id="{55DE9A48-B850-58D5-1576-8EEEB414F3D4}"/>
+              </a:ext>
+            </a:extLst>
+          </p:cNvPr>
+          <p:cNvSpPr>
+            <a:spLocks noGrp="1"/>
+          </p:cNvSpPr>
+          <p:nvPr>
+            <p:ph type="title"/>
           </p:nvPr>
         </p:nvSpPr>
         <p:spPr/>
@@ -4182,52 +4775,116 @@
           <a:p>
             <a:r>
               <a:rPr lang="en-US" dirty="0"/>
-              <a:t>Blackwater Manor </a:t>
-            </a:r>
-            <a:br>
-              <a:rPr lang="en-US" dirty="0"/>
-            </a:br>
-            <a:r>
-              <a:rPr lang="en-US" dirty="0"/>
-              <a:t>Coding Escape Room</a:t>
-            </a:r>
-          </a:p>
-        </p:txBody>
-      </p:sp>
-      <p:sp>
-        <p:nvSpPr>
-          <p:cNvPr id="3" name="Subtitle 2">
-            <a:extLst>
-              <a:ext uri="{FF2B5EF4-FFF2-40B4-BE49-F238E27FC236}">
-                <a16:creationId xmlns:a16="http://schemas.microsoft.com/office/drawing/2014/main" id="{4223BF77-ED66-A312-856C-58A0E22DD7A4}"/>
-              </a:ext>
-            </a:extLst>
-          </p:cNvPr>
-          <p:cNvSpPr>
-            <a:spLocks noGrp="1"/>
-          </p:cNvSpPr>
-          <p:nvPr>
-            <p:ph type="subTitle" idx="1"/>
+              <a:t>Announcements</a:t>
+            </a:r>
+          </a:p>
+        </p:txBody>
+      </p:sp>
+      <p:sp>
+        <p:nvSpPr>
+          <p:cNvPr id="3" name="Content Placeholder 2">
+            <a:extLst>
+              <a:ext uri="{FF2B5EF4-FFF2-40B4-BE49-F238E27FC236}">
+                <a16:creationId xmlns:a16="http://schemas.microsoft.com/office/drawing/2014/main" id="{5EC916F8-2617-0B7F-D699-7AE508E9AD38}"/>
+              </a:ext>
+            </a:extLst>
+          </p:cNvPr>
+          <p:cNvSpPr>
+            <a:spLocks noGrp="1"/>
+          </p:cNvSpPr>
+          <p:nvPr>
+            <p:ph idx="1"/>
           </p:nvPr>
         </p:nvSpPr>
         <p:spPr>
           <a:xfrm>
-            <a:off x="1524000" y="4559981"/>
-            <a:ext cx="9144000" cy="1655762"/>
+            <a:off x="838200" y="1825625"/>
+            <a:ext cx="4343400" cy="4351338"/>
           </a:xfrm>
         </p:spPr>
         <p:txBody>
           <a:bodyPr/>
           <a:lstStyle/>
           <a:p>
+            <a:r>
+              <a:rPr lang="en-US" dirty="0"/>
+              <a:t>No class on Monday!</a:t>
+            </a:r>
+          </a:p>
+          <a:p>
+            <a:r>
+              <a:rPr lang="en-US" dirty="0"/>
+              <a:t>Quiz next Wednesday!</a:t>
+            </a:r>
+          </a:p>
+          <a:p>
+            <a:r>
+              <a:rPr lang="en-US" dirty="0"/>
+              <a:t>Lab 4 due tomorrow!</a:t>
+            </a:r>
+          </a:p>
+          <a:p>
+            <a:r>
+              <a:rPr lang="en-US" dirty="0"/>
+              <a:t>Next week bring your own dataset to work with</a:t>
+            </a:r>
+          </a:p>
+          <a:p>
             <a:endParaRPr lang="en-US" dirty="0"/>
           </a:p>
-        </p:txBody>
-      </p:sp>
+          <a:p>
+            <a:r>
+              <a:rPr lang="en-US" dirty="0"/>
+              <a:t>Happy </a:t>
+            </a:r>
+            <a:r>
+              <a:rPr lang="en-US" dirty="0" err="1"/>
+              <a:t>Halloweeeeennn</a:t>
+            </a:r>
+            <a:r>
+              <a:rPr lang="en-US" dirty="0"/>
+              <a:t>!</a:t>
+            </a:r>
+          </a:p>
+          <a:p>
+            <a:endParaRPr lang="en-US" dirty="0"/>
+          </a:p>
+        </p:txBody>
+      </p:sp>
+      <p:pic>
+        <p:nvPicPr>
+          <p:cNvPr id="5" name="Picture 4">
+            <a:extLst>
+              <a:ext uri="{FF2B5EF4-FFF2-40B4-BE49-F238E27FC236}">
+                <a16:creationId xmlns:a16="http://schemas.microsoft.com/office/drawing/2014/main" id="{6665DA08-0A89-1243-C600-2D30A830B216}"/>
+              </a:ext>
+            </a:extLst>
+          </p:cNvPr>
+          <p:cNvPicPr>
+            <a:picLocks noChangeAspect="1"/>
+          </p:cNvPicPr>
+          <p:nvPr/>
+        </p:nvPicPr>
+        <p:blipFill>
+          <a:blip r:embed="rId2"/>
+          <a:stretch>
+            <a:fillRect/>
+          </a:stretch>
+        </p:blipFill>
+        <p:spPr>
+          <a:xfrm>
+            <a:off x="5428632" y="253837"/>
+            <a:ext cx="6407479" cy="6350326"/>
+          </a:xfrm>
+          <a:prstGeom prst="rect">
+            <a:avLst/>
+          </a:prstGeom>
+        </p:spPr>
+      </p:pic>
     </p:spTree>
     <p:extLst>
       <p:ext uri="{BB962C8B-B14F-4D97-AF65-F5344CB8AC3E}">
-        <p14:creationId xmlns:p14="http://schemas.microsoft.com/office/powerpoint/2010/main" val="2678818095"/>
+        <p14:creationId xmlns:p14="http://schemas.microsoft.com/office/powerpoint/2010/main" val="949666939"/>
       </p:ext>
     </p:extLst>
   </p:cSld>
@@ -4254,251 +4911,129 @@
           <a:chExt cx="0" cy="0"/>
         </a:xfrm>
       </p:grpSpPr>
+      <p:sp>
+        <p:nvSpPr>
+          <p:cNvPr id="4" name="Title 1">
+            <a:extLst>
+              <a:ext uri="{FF2B5EF4-FFF2-40B4-BE49-F238E27FC236}">
+                <a16:creationId xmlns:a16="http://schemas.microsoft.com/office/drawing/2014/main" id="{EEA0337E-FB53-7813-C75A-028B4BEE19CC}"/>
+              </a:ext>
+            </a:extLst>
+          </p:cNvPr>
+          <p:cNvSpPr>
+            <a:spLocks noGrp="1"/>
+          </p:cNvSpPr>
+          <p:nvPr>
+            <p:ph type="title"/>
+          </p:nvPr>
+        </p:nvSpPr>
+        <p:spPr>
+          <a:xfrm>
+            <a:off x="590550" y="1897062"/>
+            <a:ext cx="6762750" cy="3063875"/>
+          </a:xfrm>
+        </p:spPr>
+        <p:txBody>
+          <a:bodyPr>
+            <a:normAutofit fontScale="90000"/>
+          </a:bodyPr>
+          <a:lstStyle/>
+          <a:p>
+            <a:pPr algn="ctr"/>
+            <a:r>
+              <a:rPr lang="en-US" dirty="0"/>
+              <a:t>What type of test would you use with a </a:t>
+            </a:r>
+            <a:br>
+              <a:rPr lang="en-US" dirty="0"/>
+            </a:br>
+            <a:r>
+              <a:rPr lang="en-US" b="1" dirty="0">
+                <a:solidFill>
+                  <a:schemeClr val="accent3">
+                    <a:lumMod val="60000"/>
+                    <a:lumOff val="40000"/>
+                  </a:schemeClr>
+                </a:solidFill>
+              </a:rPr>
+              <a:t>categorical explanatory variable </a:t>
+            </a:r>
+            <a:r>
+              <a:rPr lang="en-US" dirty="0"/>
+              <a:t>and a </a:t>
+            </a:r>
+            <a:br>
+              <a:rPr lang="en-US" dirty="0"/>
+            </a:br>
+            <a:r>
+              <a:rPr lang="en-US" b="1" dirty="0">
+                <a:solidFill>
+                  <a:schemeClr val="accent4">
+                    <a:lumMod val="40000"/>
+                    <a:lumOff val="60000"/>
+                  </a:schemeClr>
+                </a:solidFill>
+              </a:rPr>
+              <a:t>categorical response variable</a:t>
+            </a:r>
+            <a:r>
+              <a:rPr lang="en-US" dirty="0"/>
+              <a:t>?</a:t>
+            </a:r>
+          </a:p>
+        </p:txBody>
+      </p:sp>
       <p:pic>
         <p:nvPicPr>
-          <p:cNvPr id="4" name="Picture 3" descr="The Haunting of Crimson Manor (Horror Romance) - LifeShouts.com">
-            <a:extLst>
-              <a:ext uri="{FF2B5EF4-FFF2-40B4-BE49-F238E27FC236}">
-                <a16:creationId xmlns:a16="http://schemas.microsoft.com/office/drawing/2014/main" id="{60621E70-F632-66D5-EFA9-0A8CE0F7E53A}"/>
+          <p:cNvPr id="2050" name="Picture 2" descr="Whaaat Meme GIFs | Tenor">
+            <a:extLst>
+              <a:ext uri="{FF2B5EF4-FFF2-40B4-BE49-F238E27FC236}">
+                <a16:creationId xmlns:a16="http://schemas.microsoft.com/office/drawing/2014/main" id="{F3B678A3-D5CE-FD78-B001-A206F5DBA901}"/>
               </a:ext>
             </a:extLst>
           </p:cNvPr>
           <p:cNvPicPr>
-            <a:picLocks noChangeAspect="1"/>
+            <a:picLocks noChangeAspect="1" noChangeArrowheads="1"/>
           </p:cNvPicPr>
           <p:nvPr/>
         </p:nvPicPr>
         <p:blipFill>
-          <a:blip r:embed="rId3"/>
+          <a:blip r:embed="rId2">
+            <a:extLst>
+              <a:ext uri="{28A0092B-C50C-407E-A947-70E740481C1C}">
+                <a14:useLocalDpi xmlns:a14="http://schemas.microsoft.com/office/drawing/2010/main" val="0"/>
+              </a:ext>
+            </a:extLst>
+          </a:blip>
+          <a:srcRect/>
           <a:stretch>
             <a:fillRect/>
           </a:stretch>
         </p:blipFill>
-        <p:spPr>
+        <p:spPr bwMode="auto">
           <a:xfrm>
-            <a:off x="892628" y="459609"/>
-            <a:ext cx="10406743" cy="5938782"/>
+            <a:off x="7591425" y="1423986"/>
+            <a:ext cx="4010025" cy="4010025"/>
           </a:xfrm>
           <a:prstGeom prst="rect">
             <a:avLst/>
           </a:prstGeom>
+          <a:noFill/>
+          <a:extLst>
+            <a:ext uri="{909E8E84-426E-40DD-AFC4-6F175D3DCCD1}">
+              <a14:hiddenFill xmlns:a14="http://schemas.microsoft.com/office/drawing/2010/main">
+                <a:solidFill>
+                  <a:srgbClr val="FFFFFF"/>
+                </a:solidFill>
+              </a14:hiddenFill>
+            </a:ext>
+          </a:extLst>
         </p:spPr>
       </p:pic>
-      <p:sp>
-        <p:nvSpPr>
-          <p:cNvPr id="5" name="Content Placeholder 2">
-            <a:extLst>
-              <a:ext uri="{FF2B5EF4-FFF2-40B4-BE49-F238E27FC236}">
-                <a16:creationId xmlns:a16="http://schemas.microsoft.com/office/drawing/2014/main" id="{CFFF9CA3-3824-81D0-5D75-5B50DC9CB6A0}"/>
-              </a:ext>
-            </a:extLst>
-          </p:cNvPr>
-          <p:cNvSpPr txBox="1">
-            <a:spLocks/>
-          </p:cNvSpPr>
-          <p:nvPr/>
-        </p:nvSpPr>
-        <p:spPr>
-          <a:xfrm>
-            <a:off x="-745672" y="6539139"/>
-            <a:ext cx="13683342" cy="318861"/>
-          </a:xfrm>
-          <a:prstGeom prst="rect">
-            <a:avLst/>
-          </a:prstGeom>
-        </p:spPr>
-        <p:txBody>
-          <a:bodyPr vert="horz" lIns="91440" tIns="45720" rIns="91440" bIns="45720" rtlCol="0">
-            <a:normAutofit fontScale="77500" lnSpcReduction="20000"/>
-          </a:bodyPr>
-          <a:lstStyle>
-            <a:lvl1pPr marL="0" indent="0" algn="ctr" defTabSz="914400" rtl="0" eaLnBrk="1" latinLnBrk="0" hangingPunct="1">
-              <a:lnSpc>
-                <a:spcPct val="90000"/>
-              </a:lnSpc>
-              <a:spcBef>
-                <a:spcPts val="1000"/>
-              </a:spcBef>
-              <a:buFont typeface="Arial" panose="020B0604020202020204" pitchFamily="34" charset="0"/>
-              <a:buNone/>
-              <a:defRPr sz="2400" kern="1200">
-                <a:solidFill>
-                  <a:schemeClr val="tx1"/>
-                </a:solidFill>
-                <a:latin typeface="+mn-lt"/>
-                <a:ea typeface="+mn-ea"/>
-                <a:cs typeface="+mn-cs"/>
-              </a:defRPr>
-            </a:lvl1pPr>
-            <a:lvl2pPr marL="457200" indent="0" algn="ctr" defTabSz="914400" rtl="0" eaLnBrk="1" latinLnBrk="0" hangingPunct="1">
-              <a:lnSpc>
-                <a:spcPct val="90000"/>
-              </a:lnSpc>
-              <a:spcBef>
-                <a:spcPts val="500"/>
-              </a:spcBef>
-              <a:buFont typeface="Arial" panose="020B0604020202020204" pitchFamily="34" charset="0"/>
-              <a:buNone/>
-              <a:defRPr sz="2000" kern="1200">
-                <a:solidFill>
-                  <a:schemeClr val="tx1"/>
-                </a:solidFill>
-                <a:latin typeface="+mn-lt"/>
-                <a:ea typeface="+mn-ea"/>
-                <a:cs typeface="+mn-cs"/>
-              </a:defRPr>
-            </a:lvl2pPr>
-            <a:lvl3pPr marL="914400" indent="0" algn="ctr" defTabSz="914400" rtl="0" eaLnBrk="1" latinLnBrk="0" hangingPunct="1">
-              <a:lnSpc>
-                <a:spcPct val="90000"/>
-              </a:lnSpc>
-              <a:spcBef>
-                <a:spcPts val="500"/>
-              </a:spcBef>
-              <a:buFont typeface="Arial" panose="020B0604020202020204" pitchFamily="34" charset="0"/>
-              <a:buNone/>
-              <a:defRPr sz="1800" kern="1200">
-                <a:solidFill>
-                  <a:schemeClr val="tx1"/>
-                </a:solidFill>
-                <a:latin typeface="+mn-lt"/>
-                <a:ea typeface="+mn-ea"/>
-                <a:cs typeface="+mn-cs"/>
-              </a:defRPr>
-            </a:lvl3pPr>
-            <a:lvl4pPr marL="1371600" indent="0" algn="ctr" defTabSz="914400" rtl="0" eaLnBrk="1" latinLnBrk="0" hangingPunct="1">
-              <a:lnSpc>
-                <a:spcPct val="90000"/>
-              </a:lnSpc>
-              <a:spcBef>
-                <a:spcPts val="500"/>
-              </a:spcBef>
-              <a:buFont typeface="Arial" panose="020B0604020202020204" pitchFamily="34" charset="0"/>
-              <a:buNone/>
-              <a:defRPr sz="1600" kern="1200">
-                <a:solidFill>
-                  <a:schemeClr val="tx1"/>
-                </a:solidFill>
-                <a:latin typeface="+mn-lt"/>
-                <a:ea typeface="+mn-ea"/>
-                <a:cs typeface="+mn-cs"/>
-              </a:defRPr>
-            </a:lvl4pPr>
-            <a:lvl5pPr marL="1828800" indent="0" algn="ctr" defTabSz="914400" rtl="0" eaLnBrk="1" latinLnBrk="0" hangingPunct="1">
-              <a:lnSpc>
-                <a:spcPct val="90000"/>
-              </a:lnSpc>
-              <a:spcBef>
-                <a:spcPts val="500"/>
-              </a:spcBef>
-              <a:buFont typeface="Arial" panose="020B0604020202020204" pitchFamily="34" charset="0"/>
-              <a:buNone/>
-              <a:defRPr sz="1600" kern="1200">
-                <a:solidFill>
-                  <a:schemeClr val="tx1"/>
-                </a:solidFill>
-                <a:latin typeface="+mn-lt"/>
-                <a:ea typeface="+mn-ea"/>
-                <a:cs typeface="+mn-cs"/>
-              </a:defRPr>
-            </a:lvl5pPr>
-            <a:lvl6pPr marL="2286000" indent="0" algn="ctr" defTabSz="914400" rtl="0" eaLnBrk="1" latinLnBrk="0" hangingPunct="1">
-              <a:lnSpc>
-                <a:spcPct val="90000"/>
-              </a:lnSpc>
-              <a:spcBef>
-                <a:spcPts val="500"/>
-              </a:spcBef>
-              <a:buFont typeface="Arial" panose="020B0604020202020204" pitchFamily="34" charset="0"/>
-              <a:buNone/>
-              <a:defRPr sz="1600" kern="1200">
-                <a:solidFill>
-                  <a:schemeClr val="tx1"/>
-                </a:solidFill>
-                <a:latin typeface="+mn-lt"/>
-                <a:ea typeface="+mn-ea"/>
-                <a:cs typeface="+mn-cs"/>
-              </a:defRPr>
-            </a:lvl6pPr>
-            <a:lvl7pPr marL="2743200" indent="0" algn="ctr" defTabSz="914400" rtl="0" eaLnBrk="1" latinLnBrk="0" hangingPunct="1">
-              <a:lnSpc>
-                <a:spcPct val="90000"/>
-              </a:lnSpc>
-              <a:spcBef>
-                <a:spcPts val="500"/>
-              </a:spcBef>
-              <a:buFont typeface="Arial" panose="020B0604020202020204" pitchFamily="34" charset="0"/>
-              <a:buNone/>
-              <a:defRPr sz="1600" kern="1200">
-                <a:solidFill>
-                  <a:schemeClr val="tx1"/>
-                </a:solidFill>
-                <a:latin typeface="+mn-lt"/>
-                <a:ea typeface="+mn-ea"/>
-                <a:cs typeface="+mn-cs"/>
-              </a:defRPr>
-            </a:lvl7pPr>
-            <a:lvl8pPr marL="3200400" indent="0" algn="ctr" defTabSz="914400" rtl="0" eaLnBrk="1" latinLnBrk="0" hangingPunct="1">
-              <a:lnSpc>
-                <a:spcPct val="90000"/>
-              </a:lnSpc>
-              <a:spcBef>
-                <a:spcPts val="500"/>
-              </a:spcBef>
-              <a:buFont typeface="Arial" panose="020B0604020202020204" pitchFamily="34" charset="0"/>
-              <a:buNone/>
-              <a:defRPr sz="1600" kern="1200">
-                <a:solidFill>
-                  <a:schemeClr val="tx1"/>
-                </a:solidFill>
-                <a:latin typeface="+mn-lt"/>
-                <a:ea typeface="+mn-ea"/>
-                <a:cs typeface="+mn-cs"/>
-              </a:defRPr>
-            </a:lvl8pPr>
-            <a:lvl9pPr marL="3657600" indent="0" algn="ctr" defTabSz="914400" rtl="0" eaLnBrk="1" latinLnBrk="0" hangingPunct="1">
-              <a:lnSpc>
-                <a:spcPct val="90000"/>
-              </a:lnSpc>
-              <a:spcBef>
-                <a:spcPts val="500"/>
-              </a:spcBef>
-              <a:buFont typeface="Arial" panose="020B0604020202020204" pitchFamily="34" charset="0"/>
-              <a:buNone/>
-              <a:defRPr sz="1600" kern="1200">
-                <a:solidFill>
-                  <a:schemeClr val="tx1"/>
-                </a:solidFill>
-                <a:latin typeface="+mn-lt"/>
-                <a:ea typeface="+mn-ea"/>
-                <a:cs typeface="+mn-cs"/>
-              </a:defRPr>
-            </a:lvl9pPr>
-          </a:lstStyle>
-          <a:p>
-            <a:r>
-              <a:rPr lang="en-US" dirty="0">
-                <a:hlinkClick r:id="rId4">
-                  <a:extLst>
-                    <a:ext uri="{A12FA001-AC4F-418D-AE19-62706E023703}">
-                      <ahyp:hlinkClr xmlns:ahyp="http://schemas.microsoft.com/office/drawing/2018/hyperlinkcolor" val="tx"/>
-                    </a:ext>
-                  </a:extLst>
-                </a:hlinkClick>
-              </a:rPr>
-              <a:t>https://kmblincow-the-blackwater-manor-incident.share.connect.posit.cloud/</a:t>
-            </a:r>
-            <a:r>
-              <a:rPr lang="en-US" dirty="0"/>
-              <a:t> </a:t>
-            </a:r>
-          </a:p>
-        </p:txBody>
-      </p:sp>
     </p:spTree>
     <p:extLst>
       <p:ext uri="{BB962C8B-B14F-4D97-AF65-F5344CB8AC3E}">
-        <p14:creationId xmlns:p14="http://schemas.microsoft.com/office/powerpoint/2010/main" val="157032003"/>
+        <p14:creationId xmlns:p14="http://schemas.microsoft.com/office/powerpoint/2010/main" val="3207386173"/>
       </p:ext>
     </p:extLst>
   </p:cSld>
@@ -4530,7 +5065,7 @@
           <p:cNvPr id="2" name="Title 1">
             <a:extLst>
               <a:ext uri="{FF2B5EF4-FFF2-40B4-BE49-F238E27FC236}">
-                <a16:creationId xmlns:a16="http://schemas.microsoft.com/office/drawing/2014/main" id="{67A4400D-801D-55F5-D2BB-237C15C3BE05}"/>
+                <a16:creationId xmlns:a16="http://schemas.microsoft.com/office/drawing/2014/main" id="{346B4E2C-F5FD-4734-FF01-CB2ECAF9E59C}"/>
               </a:ext>
             </a:extLst>
           </p:cNvPr>
@@ -4546,39 +5081,1174 @@
           <a:bodyPr/>
           <a:lstStyle/>
           <a:p>
-            <a:endParaRPr lang="en-US" dirty="0"/>
-          </a:p>
-        </p:txBody>
-      </p:sp>
-      <p:sp>
-        <p:nvSpPr>
-          <p:cNvPr id="5" name="Content Placeholder 4">
-            <a:extLst>
-              <a:ext uri="{FF2B5EF4-FFF2-40B4-BE49-F238E27FC236}">
-                <a16:creationId xmlns:a16="http://schemas.microsoft.com/office/drawing/2014/main" id="{D0170FCA-CA42-4394-418A-F0C78792291E}"/>
-              </a:ext>
-            </a:extLst>
-          </p:cNvPr>
-          <p:cNvSpPr>
-            <a:spLocks noGrp="1"/>
-          </p:cNvSpPr>
-          <p:nvPr>
-            <p:ph idx="1"/>
-          </p:nvPr>
-        </p:nvSpPr>
-        <p:spPr/>
-        <p:txBody>
-          <a:bodyPr/>
-          <a:lstStyle/>
-          <a:p>
-            <a:endParaRPr lang="en-US"/>
-          </a:p>
-        </p:txBody>
-      </p:sp>
+            <a:pPr algn="ctr"/>
+            <a:r>
+              <a:rPr lang="en-US" b="1" dirty="0"/>
+              <a:t>Enter Analysis of Frequencies!</a:t>
+            </a:r>
+          </a:p>
+        </p:txBody>
+      </p:sp>
+      <p:pic>
+        <p:nvPicPr>
+          <p:cNvPr id="3076" name="Picture 4" descr="Grand Entrance Kuzco GIF - Grand Entrance Kuzco The Emperors New Groove -  Discover &amp; Share GIFs">
+            <a:extLst>
+              <a:ext uri="{FF2B5EF4-FFF2-40B4-BE49-F238E27FC236}">
+                <a16:creationId xmlns:a16="http://schemas.microsoft.com/office/drawing/2014/main" id="{69DB34B3-2FC5-BD64-37D3-DD392D856B53}"/>
+              </a:ext>
+            </a:extLst>
+          </p:cNvPr>
+          <p:cNvPicPr>
+            <a:picLocks noChangeAspect="1" noChangeArrowheads="1"/>
+          </p:cNvPicPr>
+          <p:nvPr/>
+        </p:nvPicPr>
+        <p:blipFill>
+          <a:blip r:embed="rId2">
+            <a:extLst>
+              <a:ext uri="{28A0092B-C50C-407E-A947-70E740481C1C}">
+                <a14:useLocalDpi xmlns:a14="http://schemas.microsoft.com/office/drawing/2010/main" val="0"/>
+              </a:ext>
+            </a:extLst>
+          </a:blip>
+          <a:srcRect/>
+          <a:stretch>
+            <a:fillRect/>
+          </a:stretch>
+        </p:blipFill>
+        <p:spPr bwMode="auto">
+          <a:xfrm>
+            <a:off x="2960774" y="2381250"/>
+            <a:ext cx="6270451" cy="3676650"/>
+          </a:xfrm>
+          <a:prstGeom prst="rect">
+            <a:avLst/>
+          </a:prstGeom>
+          <a:noFill/>
+          <a:extLst>
+            <a:ext uri="{909E8E84-426E-40DD-AFC4-6F175D3DCCD1}">
+              <a14:hiddenFill xmlns:a14="http://schemas.microsoft.com/office/drawing/2010/main">
+                <a:solidFill>
+                  <a:srgbClr val="FFFFFF"/>
+                </a:solidFill>
+              </a14:hiddenFill>
+            </a:ext>
+          </a:extLst>
+        </p:spPr>
+      </p:pic>
     </p:spTree>
     <p:extLst>
       <p:ext uri="{BB962C8B-B14F-4D97-AF65-F5344CB8AC3E}">
-        <p14:creationId xmlns:p14="http://schemas.microsoft.com/office/powerpoint/2010/main" val="386430998"/>
+        <p14:creationId xmlns:p14="http://schemas.microsoft.com/office/powerpoint/2010/main" val="1938947169"/>
+      </p:ext>
+    </p:extLst>
+  </p:cSld>
+  <p:clrMapOvr>
+    <a:masterClrMapping/>
+  </p:clrMapOvr>
+</p:sld>
+</file>
+
+<file path=ppt/slides/slide5.xml><?xml version="1.0" encoding="utf-8"?>
+<p:sld xmlns:a="http://schemas.openxmlformats.org/drawingml/2006/main" xmlns:r="http://schemas.openxmlformats.org/officeDocument/2006/relationships" xmlns:p="http://schemas.openxmlformats.org/presentationml/2006/main">
+  <p:cSld>
+    <p:spTree>
+      <p:nvGrpSpPr>
+        <p:cNvPr id="1" name=""/>
+        <p:cNvGrpSpPr/>
+        <p:nvPr/>
+      </p:nvGrpSpPr>
+      <p:grpSpPr>
+        <a:xfrm>
+          <a:off x="0" y="0"/>
+          <a:ext cx="0" cy="0"/>
+          <a:chOff x="0" y="0"/>
+          <a:chExt cx="0" cy="0"/>
+        </a:xfrm>
+      </p:grpSpPr>
+      <p:sp>
+        <p:nvSpPr>
+          <p:cNvPr id="2" name="Title 1">
+            <a:extLst>
+              <a:ext uri="{FF2B5EF4-FFF2-40B4-BE49-F238E27FC236}">
+                <a16:creationId xmlns:a16="http://schemas.microsoft.com/office/drawing/2014/main" id="{E1FB17D6-6F66-19BD-2429-C3FC9E39EE75}"/>
+              </a:ext>
+            </a:extLst>
+          </p:cNvPr>
+          <p:cNvSpPr>
+            <a:spLocks noGrp="1"/>
+          </p:cNvSpPr>
+          <p:nvPr>
+            <p:ph type="title"/>
+          </p:nvPr>
+        </p:nvSpPr>
+        <p:spPr/>
+        <p:txBody>
+          <a:bodyPr/>
+          <a:lstStyle/>
+          <a:p>
+            <a:r>
+              <a:rPr lang="en-US" dirty="0"/>
+              <a:t>What is a frequency?</a:t>
+            </a:r>
+          </a:p>
+        </p:txBody>
+      </p:sp>
+      <p:sp>
+        <p:nvSpPr>
+          <p:cNvPr id="3" name="Content Placeholder 2">
+            <a:extLst>
+              <a:ext uri="{FF2B5EF4-FFF2-40B4-BE49-F238E27FC236}">
+                <a16:creationId xmlns:a16="http://schemas.microsoft.com/office/drawing/2014/main" id="{A5D8D2CC-3ABA-592D-343B-8D940243FE31}"/>
+              </a:ext>
+            </a:extLst>
+          </p:cNvPr>
+          <p:cNvSpPr>
+            <a:spLocks noGrp="1"/>
+          </p:cNvSpPr>
+          <p:nvPr>
+            <p:ph idx="1"/>
+          </p:nvPr>
+        </p:nvSpPr>
+        <p:spPr/>
+        <p:txBody>
+          <a:bodyPr/>
+          <a:lstStyle/>
+          <a:p>
+            <a:r>
+              <a:rPr lang="en-US" dirty="0"/>
+              <a:t>counts of observations that fall into categories</a:t>
+            </a:r>
+          </a:p>
+        </p:txBody>
+      </p:sp>
+      <p:pic>
+        <p:nvPicPr>
+          <p:cNvPr id="4" name="Picture 4" descr="Oh, you like to use big words? you must be so smart - Condescending Wonka -  quickmeme">
+            <a:extLst>
+              <a:ext uri="{FF2B5EF4-FFF2-40B4-BE49-F238E27FC236}">
+                <a16:creationId xmlns:a16="http://schemas.microsoft.com/office/drawing/2014/main" id="{CC85493E-78DE-63E2-792D-33EEC3FBEEF8}"/>
+              </a:ext>
+            </a:extLst>
+          </p:cNvPr>
+          <p:cNvPicPr>
+            <a:picLocks noChangeAspect="1" noChangeArrowheads="1"/>
+          </p:cNvPicPr>
+          <p:nvPr/>
+        </p:nvPicPr>
+        <p:blipFill>
+          <a:blip r:embed="rId2">
+            <a:extLst>
+              <a:ext uri="{28A0092B-C50C-407E-A947-70E740481C1C}">
+                <a14:useLocalDpi xmlns:a14="http://schemas.microsoft.com/office/drawing/2010/main" val="0"/>
+              </a:ext>
+            </a:extLst>
+          </a:blip>
+          <a:srcRect/>
+          <a:stretch>
+            <a:fillRect/>
+          </a:stretch>
+        </p:blipFill>
+        <p:spPr bwMode="auto">
+          <a:xfrm>
+            <a:off x="9190688" y="955436"/>
+            <a:ext cx="1605442" cy="1605442"/>
+          </a:xfrm>
+          <a:prstGeom prst="rect">
+            <a:avLst/>
+          </a:prstGeom>
+          <a:noFill/>
+          <a:extLst>
+            <a:ext uri="{909E8E84-426E-40DD-AFC4-6F175D3DCCD1}">
+              <a14:hiddenFill xmlns:a14="http://schemas.microsoft.com/office/drawing/2010/main">
+                <a:solidFill>
+                  <a:srgbClr val="FFFFFF"/>
+                </a:solidFill>
+              </a14:hiddenFill>
+            </a:ext>
+          </a:extLst>
+        </p:spPr>
+      </p:pic>
+      <p:pic>
+        <p:nvPicPr>
+          <p:cNvPr id="5" name="Picture 4" descr="New Sesame Street Count Memes | Ah Ah Ah Memes">
+            <a:extLst>
+              <a:ext uri="{FF2B5EF4-FFF2-40B4-BE49-F238E27FC236}">
+                <a16:creationId xmlns:a16="http://schemas.microsoft.com/office/drawing/2014/main" id="{8843FDD0-5EE1-C67F-F585-2C0DD8F32994}"/>
+              </a:ext>
+            </a:extLst>
+          </p:cNvPr>
+          <p:cNvPicPr>
+            <a:picLocks noChangeAspect="1" noChangeArrowheads="1"/>
+          </p:cNvPicPr>
+          <p:nvPr/>
+        </p:nvPicPr>
+        <p:blipFill>
+          <a:blip r:embed="rId3">
+            <a:extLst>
+              <a:ext uri="{28A0092B-C50C-407E-A947-70E740481C1C}">
+                <a14:useLocalDpi xmlns:a14="http://schemas.microsoft.com/office/drawing/2010/main" val="0"/>
+              </a:ext>
+            </a:extLst>
+          </a:blip>
+          <a:srcRect/>
+          <a:stretch>
+            <a:fillRect/>
+          </a:stretch>
+        </p:blipFill>
+        <p:spPr bwMode="auto">
+          <a:xfrm>
+            <a:off x="3714751" y="3429000"/>
+            <a:ext cx="3836352" cy="2557568"/>
+          </a:xfrm>
+          <a:prstGeom prst="rect">
+            <a:avLst/>
+          </a:prstGeom>
+          <a:noFill/>
+          <a:extLst>
+            <a:ext uri="{909E8E84-426E-40DD-AFC4-6F175D3DCCD1}">
+              <a14:hiddenFill xmlns:a14="http://schemas.microsoft.com/office/drawing/2010/main">
+                <a:solidFill>
+                  <a:srgbClr val="FFFFFF"/>
+                </a:solidFill>
+              </a14:hiddenFill>
+            </a:ext>
+          </a:extLst>
+        </p:spPr>
+      </p:pic>
+    </p:spTree>
+    <p:extLst>
+      <p:ext uri="{BB962C8B-B14F-4D97-AF65-F5344CB8AC3E}">
+        <p14:creationId xmlns:p14="http://schemas.microsoft.com/office/powerpoint/2010/main" val="285636063"/>
+      </p:ext>
+    </p:extLst>
+  </p:cSld>
+  <p:clrMapOvr>
+    <a:masterClrMapping/>
+  </p:clrMapOvr>
+</p:sld>
+</file>
+
+<file path=ppt/slides/slide6.xml><?xml version="1.0" encoding="utf-8"?>
+<p:sld xmlns:a="http://schemas.openxmlformats.org/drawingml/2006/main" xmlns:r="http://schemas.openxmlformats.org/officeDocument/2006/relationships" xmlns:p="http://schemas.openxmlformats.org/presentationml/2006/main">
+  <p:cSld>
+    <p:spTree>
+      <p:nvGrpSpPr>
+        <p:cNvPr id="1" name=""/>
+        <p:cNvGrpSpPr/>
+        <p:nvPr/>
+      </p:nvGrpSpPr>
+      <p:grpSpPr>
+        <a:xfrm>
+          <a:off x="0" y="0"/>
+          <a:ext cx="0" cy="0"/>
+          <a:chOff x="0" y="0"/>
+          <a:chExt cx="0" cy="0"/>
+        </a:xfrm>
+      </p:grpSpPr>
+      <p:sp>
+        <p:nvSpPr>
+          <p:cNvPr id="2" name="Title 1">
+            <a:extLst>
+              <a:ext uri="{FF2B5EF4-FFF2-40B4-BE49-F238E27FC236}">
+                <a16:creationId xmlns:a16="http://schemas.microsoft.com/office/drawing/2014/main" id="{55B9A232-4A52-E324-DEB8-6DDECD16CDFC}"/>
+              </a:ext>
+            </a:extLst>
+          </p:cNvPr>
+          <p:cNvSpPr>
+            <a:spLocks noGrp="1"/>
+          </p:cNvSpPr>
+          <p:nvPr>
+            <p:ph type="title"/>
+          </p:nvPr>
+        </p:nvSpPr>
+        <p:spPr/>
+        <p:txBody>
+          <a:bodyPr/>
+          <a:lstStyle/>
+          <a:p>
+            <a:r>
+              <a:rPr lang="en-US" dirty="0"/>
+              <a:t>Types of Questions</a:t>
+            </a:r>
+          </a:p>
+        </p:txBody>
+      </p:sp>
+      <p:sp>
+        <p:nvSpPr>
+          <p:cNvPr id="3" name="Content Placeholder 2">
+            <a:extLst>
+              <a:ext uri="{FF2B5EF4-FFF2-40B4-BE49-F238E27FC236}">
+                <a16:creationId xmlns:a16="http://schemas.microsoft.com/office/drawing/2014/main" id="{8F934F3B-8A74-4801-C343-D82DB6228A84}"/>
+              </a:ext>
+            </a:extLst>
+          </p:cNvPr>
+          <p:cNvSpPr>
+            <a:spLocks noGrp="1"/>
+          </p:cNvSpPr>
+          <p:nvPr>
+            <p:ph idx="1"/>
+          </p:nvPr>
+        </p:nvSpPr>
+        <p:spPr/>
+        <p:txBody>
+          <a:bodyPr/>
+          <a:lstStyle/>
+          <a:p>
+            <a:r>
+              <a:rPr lang="en-US" dirty="0"/>
+              <a:t>Does my distribution of frequencies across each category match the expected distribution across categories?</a:t>
+            </a:r>
+          </a:p>
+          <a:p>
+            <a:r>
+              <a:rPr lang="en-US" dirty="0"/>
+              <a:t>Does the distribution of frequencies across one categorical variable affect the distribution of frequencies across another categorial variable?</a:t>
+            </a:r>
+          </a:p>
+          <a:p>
+            <a:r>
+              <a:rPr lang="en-US" dirty="0"/>
+              <a:t>What is the likelihood that two distributions of frequencies come from the same population?</a:t>
+            </a:r>
+          </a:p>
+        </p:txBody>
+      </p:sp>
+    </p:spTree>
+    <p:extLst>
+      <p:ext uri="{BB962C8B-B14F-4D97-AF65-F5344CB8AC3E}">
+        <p14:creationId xmlns:p14="http://schemas.microsoft.com/office/powerpoint/2010/main" val="2160442981"/>
+      </p:ext>
+    </p:extLst>
+  </p:cSld>
+  <p:clrMapOvr>
+    <a:masterClrMapping/>
+  </p:clrMapOvr>
+</p:sld>
+</file>
+
+<file path=ppt/slides/slide7.xml><?xml version="1.0" encoding="utf-8"?>
+<p:sld xmlns:a="http://schemas.openxmlformats.org/drawingml/2006/main" xmlns:r="http://schemas.openxmlformats.org/officeDocument/2006/relationships" xmlns:p="http://schemas.openxmlformats.org/presentationml/2006/main">
+  <p:cSld>
+    <p:spTree>
+      <p:nvGrpSpPr>
+        <p:cNvPr id="1" name=""/>
+        <p:cNvGrpSpPr/>
+        <p:nvPr/>
+      </p:nvGrpSpPr>
+      <p:grpSpPr>
+        <a:xfrm>
+          <a:off x="0" y="0"/>
+          <a:ext cx="0" cy="0"/>
+          <a:chOff x="0" y="0"/>
+          <a:chExt cx="0" cy="0"/>
+        </a:xfrm>
+      </p:grpSpPr>
+      <p:sp>
+        <p:nvSpPr>
+          <p:cNvPr id="2" name="Title 1">
+            <a:extLst>
+              <a:ext uri="{FF2B5EF4-FFF2-40B4-BE49-F238E27FC236}">
+                <a16:creationId xmlns:a16="http://schemas.microsoft.com/office/drawing/2014/main" id="{E4FB30AD-366C-048F-D8D6-334435C5C861}"/>
+              </a:ext>
+            </a:extLst>
+          </p:cNvPr>
+          <p:cNvSpPr>
+            <a:spLocks noGrp="1"/>
+          </p:cNvSpPr>
+          <p:nvPr>
+            <p:ph type="title"/>
+          </p:nvPr>
+        </p:nvSpPr>
+        <p:spPr/>
+        <p:txBody>
+          <a:bodyPr/>
+          <a:lstStyle/>
+          <a:p>
+            <a:r>
+              <a:rPr lang="en-US" dirty="0"/>
+              <a:t>Research Scenario!</a:t>
+            </a:r>
+          </a:p>
+        </p:txBody>
+      </p:sp>
+      <p:sp>
+        <p:nvSpPr>
+          <p:cNvPr id="3" name="Content Placeholder 2">
+            <a:extLst>
+              <a:ext uri="{FF2B5EF4-FFF2-40B4-BE49-F238E27FC236}">
+                <a16:creationId xmlns:a16="http://schemas.microsoft.com/office/drawing/2014/main" id="{FB16D2AC-E871-E6D6-6740-103FD877998D}"/>
+              </a:ext>
+            </a:extLst>
+          </p:cNvPr>
+          <p:cNvSpPr>
+            <a:spLocks noGrp="1"/>
+          </p:cNvSpPr>
+          <p:nvPr>
+            <p:ph idx="1"/>
+          </p:nvPr>
+        </p:nvSpPr>
+        <p:spPr>
+          <a:xfrm>
+            <a:off x="838200" y="1690688"/>
+            <a:ext cx="10515600" cy="4486275"/>
+          </a:xfrm>
+        </p:spPr>
+        <p:txBody>
+          <a:bodyPr/>
+          <a:lstStyle/>
+          <a:p>
+            <a:r>
+              <a:rPr lang="en-US" dirty="0"/>
+              <a:t>We are doing some big ship science!</a:t>
+            </a:r>
+          </a:p>
+          <a:p>
+            <a:r>
+              <a:rPr lang="en-US" dirty="0"/>
+              <a:t>Sample copepods during an El Nino year</a:t>
+            </a:r>
+          </a:p>
+          <a:p>
+            <a:r>
+              <a:rPr lang="en-US" dirty="0"/>
+              <a:t>Count the number of each group</a:t>
+            </a:r>
+          </a:p>
+          <a:p>
+            <a:pPr marL="0" indent="0">
+              <a:buNone/>
+            </a:pPr>
+            <a:endParaRPr lang="en-US" dirty="0"/>
+          </a:p>
+          <a:p>
+            <a:endParaRPr lang="en-US" dirty="0"/>
+          </a:p>
+        </p:txBody>
+      </p:sp>
+      <p:pic>
+        <p:nvPicPr>
+          <p:cNvPr id="6146" name="Picture 2" descr="Photograph of a researcher retrieving a plankton net from the ocean.">
+            <a:extLst>
+              <a:ext uri="{FF2B5EF4-FFF2-40B4-BE49-F238E27FC236}">
+                <a16:creationId xmlns:a16="http://schemas.microsoft.com/office/drawing/2014/main" id="{BA357081-18B1-C743-D192-AF96B005573D}"/>
+              </a:ext>
+            </a:extLst>
+          </p:cNvPr>
+          <p:cNvPicPr>
+            <a:picLocks noChangeAspect="1" noChangeArrowheads="1"/>
+          </p:cNvPicPr>
+          <p:nvPr/>
+        </p:nvPicPr>
+        <p:blipFill>
+          <a:blip r:embed="rId2">
+            <a:extLst>
+              <a:ext uri="{28A0092B-C50C-407E-A947-70E740481C1C}">
+                <a14:useLocalDpi xmlns:a14="http://schemas.microsoft.com/office/drawing/2010/main" val="0"/>
+              </a:ext>
+            </a:extLst>
+          </a:blip>
+          <a:srcRect/>
+          <a:stretch>
+            <a:fillRect/>
+          </a:stretch>
+        </p:blipFill>
+        <p:spPr bwMode="auto">
+          <a:xfrm>
+            <a:off x="1528012" y="3429000"/>
+            <a:ext cx="4567988" cy="3045325"/>
+          </a:xfrm>
+          <a:prstGeom prst="rect">
+            <a:avLst/>
+          </a:prstGeom>
+          <a:noFill/>
+          <a:extLst>
+            <a:ext uri="{909E8E84-426E-40DD-AFC4-6F175D3DCCD1}">
+              <a14:hiddenFill xmlns:a14="http://schemas.microsoft.com/office/drawing/2010/main">
+                <a:solidFill>
+                  <a:srgbClr val="FFFFFF"/>
+                </a:solidFill>
+              </a14:hiddenFill>
+            </a:ext>
+          </a:extLst>
+        </p:spPr>
+      </p:pic>
+      <p:pic>
+        <p:nvPicPr>
+          <p:cNvPr id="6148" name="Picture 4" descr="Auxiliary General Oceanographic Research Vessel built by Dakota Creek">
+            <a:extLst>
+              <a:ext uri="{FF2B5EF4-FFF2-40B4-BE49-F238E27FC236}">
+                <a16:creationId xmlns:a16="http://schemas.microsoft.com/office/drawing/2014/main" id="{ED5B0BE9-28DC-A659-1035-84445DBBA907}"/>
+              </a:ext>
+            </a:extLst>
+          </p:cNvPr>
+          <p:cNvPicPr>
+            <a:picLocks noChangeAspect="1" noChangeArrowheads="1"/>
+          </p:cNvPicPr>
+          <p:nvPr/>
+        </p:nvPicPr>
+        <p:blipFill>
+          <a:blip r:embed="rId3">
+            <a:extLst>
+              <a:ext uri="{28A0092B-C50C-407E-A947-70E740481C1C}">
+                <a14:useLocalDpi xmlns:a14="http://schemas.microsoft.com/office/drawing/2010/main" val="0"/>
+              </a:ext>
+            </a:extLst>
+          </a:blip>
+          <a:srcRect/>
+          <a:stretch>
+            <a:fillRect/>
+          </a:stretch>
+        </p:blipFill>
+        <p:spPr bwMode="auto">
+          <a:xfrm>
+            <a:off x="6843475" y="2804159"/>
+            <a:ext cx="4893554" cy="3670166"/>
+          </a:xfrm>
+          <a:prstGeom prst="rect">
+            <a:avLst/>
+          </a:prstGeom>
+          <a:noFill/>
+          <a:extLst>
+            <a:ext uri="{909E8E84-426E-40DD-AFC4-6F175D3DCCD1}">
+              <a14:hiddenFill xmlns:a14="http://schemas.microsoft.com/office/drawing/2010/main">
+                <a:solidFill>
+                  <a:srgbClr val="FFFFFF"/>
+                </a:solidFill>
+              </a14:hiddenFill>
+            </a:ext>
+          </a:extLst>
+        </p:spPr>
+      </p:pic>
+    </p:spTree>
+    <p:extLst>
+      <p:ext uri="{BB962C8B-B14F-4D97-AF65-F5344CB8AC3E}">
+        <p14:creationId xmlns:p14="http://schemas.microsoft.com/office/powerpoint/2010/main" val="4170928680"/>
+      </p:ext>
+    </p:extLst>
+  </p:cSld>
+  <p:clrMapOvr>
+    <a:masterClrMapping/>
+  </p:clrMapOvr>
+</p:sld>
+</file>
+
+<file path=ppt/slides/slide8.xml><?xml version="1.0" encoding="utf-8"?>
+<p:sld xmlns:a="http://schemas.openxmlformats.org/drawingml/2006/main" xmlns:r="http://schemas.openxmlformats.org/officeDocument/2006/relationships" xmlns:p="http://schemas.openxmlformats.org/presentationml/2006/main">
+  <p:cSld>
+    <p:spTree>
+      <p:nvGrpSpPr>
+        <p:cNvPr id="1" name=""/>
+        <p:cNvGrpSpPr/>
+        <p:nvPr/>
+      </p:nvGrpSpPr>
+      <p:grpSpPr>
+        <a:xfrm>
+          <a:off x="0" y="0"/>
+          <a:ext cx="0" cy="0"/>
+          <a:chOff x="0" y="0"/>
+          <a:chExt cx="0" cy="0"/>
+        </a:xfrm>
+      </p:grpSpPr>
+      <p:sp>
+        <p:nvSpPr>
+          <p:cNvPr id="2" name="Title 1">
+            <a:extLst>
+              <a:ext uri="{FF2B5EF4-FFF2-40B4-BE49-F238E27FC236}">
+                <a16:creationId xmlns:a16="http://schemas.microsoft.com/office/drawing/2014/main" id="{A6964160-E275-C014-69CA-19A258CC70B0}"/>
+              </a:ext>
+            </a:extLst>
+          </p:cNvPr>
+          <p:cNvSpPr>
+            <a:spLocks noGrp="1"/>
+          </p:cNvSpPr>
+          <p:nvPr>
+            <p:ph type="title"/>
+          </p:nvPr>
+        </p:nvSpPr>
+        <p:spPr/>
+        <p:txBody>
+          <a:bodyPr/>
+          <a:lstStyle/>
+          <a:p>
+            <a:pPr algn="ctr"/>
+            <a:r>
+              <a:rPr lang="en-US" dirty="0"/>
+              <a:t>Meet the Copepods!</a:t>
+            </a:r>
+          </a:p>
+        </p:txBody>
+      </p:sp>
+      <p:sp>
+        <p:nvSpPr>
+          <p:cNvPr id="4" name="Rectangle: Rounded Corners 3">
+            <a:extLst>
+              <a:ext uri="{FF2B5EF4-FFF2-40B4-BE49-F238E27FC236}">
+                <a16:creationId xmlns:a16="http://schemas.microsoft.com/office/drawing/2014/main" id="{CEBE1AFE-2CC1-8CC3-C7AB-014FCC3418F5}"/>
+              </a:ext>
+            </a:extLst>
+          </p:cNvPr>
+          <p:cNvSpPr/>
+          <p:nvPr/>
+        </p:nvSpPr>
+        <p:spPr>
+          <a:xfrm>
+            <a:off x="552450" y="1690688"/>
+            <a:ext cx="2686050" cy="533400"/>
+          </a:xfrm>
+          <a:prstGeom prst="roundRect">
+            <a:avLst/>
+          </a:prstGeom>
+        </p:spPr>
+        <p:style>
+          <a:lnRef idx="2">
+            <a:schemeClr val="accent1">
+              <a:shade val="50000"/>
+            </a:schemeClr>
+          </a:lnRef>
+          <a:fillRef idx="1">
+            <a:schemeClr val="accent1"/>
+          </a:fillRef>
+          <a:effectRef idx="0">
+            <a:schemeClr val="accent1"/>
+          </a:effectRef>
+          <a:fontRef idx="minor">
+            <a:schemeClr val="lt1"/>
+          </a:fontRef>
+        </p:style>
+        <p:txBody>
+          <a:bodyPr rtlCol="0" anchor="ctr"/>
+          <a:lstStyle/>
+          <a:p>
+            <a:pPr algn="ctr"/>
+            <a:r>
+              <a:rPr lang="en-US" sz="2000" dirty="0"/>
+              <a:t>Calanoid</a:t>
+            </a:r>
+          </a:p>
+        </p:txBody>
+      </p:sp>
+      <p:sp>
+        <p:nvSpPr>
+          <p:cNvPr id="5" name="Rectangle: Rounded Corners 4">
+            <a:extLst>
+              <a:ext uri="{FF2B5EF4-FFF2-40B4-BE49-F238E27FC236}">
+                <a16:creationId xmlns:a16="http://schemas.microsoft.com/office/drawing/2014/main" id="{CD789EFC-D495-EDF1-F8BE-D6FA2B30D4B0}"/>
+              </a:ext>
+            </a:extLst>
+          </p:cNvPr>
+          <p:cNvSpPr/>
+          <p:nvPr/>
+        </p:nvSpPr>
+        <p:spPr>
+          <a:xfrm>
+            <a:off x="3390900" y="1690688"/>
+            <a:ext cx="2686050" cy="533400"/>
+          </a:xfrm>
+          <a:prstGeom prst="roundRect">
+            <a:avLst/>
+          </a:prstGeom>
+          <a:solidFill>
+            <a:schemeClr val="accent2"/>
+          </a:solidFill>
+          <a:ln>
+            <a:solidFill>
+              <a:schemeClr val="accent2"/>
+            </a:solidFill>
+          </a:ln>
+        </p:spPr>
+        <p:style>
+          <a:lnRef idx="2">
+            <a:schemeClr val="accent1">
+              <a:shade val="50000"/>
+            </a:schemeClr>
+          </a:lnRef>
+          <a:fillRef idx="1">
+            <a:schemeClr val="accent1"/>
+          </a:fillRef>
+          <a:effectRef idx="0">
+            <a:schemeClr val="accent1"/>
+          </a:effectRef>
+          <a:fontRef idx="minor">
+            <a:schemeClr val="lt1"/>
+          </a:fontRef>
+        </p:style>
+        <p:txBody>
+          <a:bodyPr rtlCol="0" anchor="ctr"/>
+          <a:lstStyle/>
+          <a:p>
+            <a:pPr algn="ctr"/>
+            <a:r>
+              <a:rPr lang="en-US" sz="2000" dirty="0"/>
+              <a:t>Harpacticoid</a:t>
+            </a:r>
+          </a:p>
+        </p:txBody>
+      </p:sp>
+      <p:sp>
+        <p:nvSpPr>
+          <p:cNvPr id="6" name="Rectangle: Rounded Corners 5">
+            <a:extLst>
+              <a:ext uri="{FF2B5EF4-FFF2-40B4-BE49-F238E27FC236}">
+                <a16:creationId xmlns:a16="http://schemas.microsoft.com/office/drawing/2014/main" id="{13563D59-37B3-9A0D-3FA5-F735270A97F4}"/>
+              </a:ext>
+            </a:extLst>
+          </p:cNvPr>
+          <p:cNvSpPr/>
+          <p:nvPr/>
+        </p:nvSpPr>
+        <p:spPr>
+          <a:xfrm>
+            <a:off x="6229350" y="1690688"/>
+            <a:ext cx="2686050" cy="533400"/>
+          </a:xfrm>
+          <a:prstGeom prst="roundRect">
+            <a:avLst/>
+          </a:prstGeom>
+          <a:solidFill>
+            <a:schemeClr val="accent3"/>
+          </a:solidFill>
+          <a:ln>
+            <a:solidFill>
+              <a:schemeClr val="accent3"/>
+            </a:solidFill>
+          </a:ln>
+        </p:spPr>
+        <p:style>
+          <a:lnRef idx="2">
+            <a:schemeClr val="accent1">
+              <a:shade val="50000"/>
+            </a:schemeClr>
+          </a:lnRef>
+          <a:fillRef idx="1">
+            <a:schemeClr val="accent1"/>
+          </a:fillRef>
+          <a:effectRef idx="0">
+            <a:schemeClr val="accent1"/>
+          </a:effectRef>
+          <a:fontRef idx="minor">
+            <a:schemeClr val="lt1"/>
+          </a:fontRef>
+        </p:style>
+        <p:txBody>
+          <a:bodyPr rtlCol="0" anchor="ctr"/>
+          <a:lstStyle/>
+          <a:p>
+            <a:pPr algn="ctr"/>
+            <a:r>
+              <a:rPr lang="en-US" sz="2000" dirty="0"/>
+              <a:t>Cyclopoid</a:t>
+            </a:r>
+          </a:p>
+        </p:txBody>
+      </p:sp>
+      <p:sp>
+        <p:nvSpPr>
+          <p:cNvPr id="7" name="Rectangle: Rounded Corners 6">
+            <a:extLst>
+              <a:ext uri="{FF2B5EF4-FFF2-40B4-BE49-F238E27FC236}">
+                <a16:creationId xmlns:a16="http://schemas.microsoft.com/office/drawing/2014/main" id="{BC952CC2-91AD-8C6F-E787-ADF8BEF6B501}"/>
+              </a:ext>
+            </a:extLst>
+          </p:cNvPr>
+          <p:cNvSpPr/>
+          <p:nvPr/>
+        </p:nvSpPr>
+        <p:spPr>
+          <a:xfrm>
+            <a:off x="9067800" y="1690688"/>
+            <a:ext cx="2686050" cy="533400"/>
+          </a:xfrm>
+          <a:prstGeom prst="roundRect">
+            <a:avLst/>
+          </a:prstGeom>
+          <a:solidFill>
+            <a:schemeClr val="accent4"/>
+          </a:solidFill>
+          <a:ln>
+            <a:solidFill>
+              <a:schemeClr val="accent4"/>
+            </a:solidFill>
+          </a:ln>
+        </p:spPr>
+        <p:style>
+          <a:lnRef idx="2">
+            <a:schemeClr val="accent1">
+              <a:shade val="50000"/>
+            </a:schemeClr>
+          </a:lnRef>
+          <a:fillRef idx="1">
+            <a:schemeClr val="accent1"/>
+          </a:fillRef>
+          <a:effectRef idx="0">
+            <a:schemeClr val="accent1"/>
+          </a:effectRef>
+          <a:fontRef idx="minor">
+            <a:schemeClr val="lt1"/>
+          </a:fontRef>
+        </p:style>
+        <p:txBody>
+          <a:bodyPr rtlCol="0" anchor="ctr"/>
+          <a:lstStyle/>
+          <a:p>
+            <a:pPr algn="ctr"/>
+            <a:r>
+              <a:rPr lang="en-US" sz="2000" dirty="0"/>
+              <a:t>Poecilostomatoid</a:t>
+            </a:r>
+          </a:p>
+        </p:txBody>
+      </p:sp>
+      <p:pic>
+        <p:nvPicPr>
+          <p:cNvPr id="5122" name="Picture 2" descr="Calanoida - Wikipedia">
+            <a:extLst>
+              <a:ext uri="{FF2B5EF4-FFF2-40B4-BE49-F238E27FC236}">
+                <a16:creationId xmlns:a16="http://schemas.microsoft.com/office/drawing/2014/main" id="{277048F1-F572-806F-BFFF-28A6419BCC09}"/>
+              </a:ext>
+            </a:extLst>
+          </p:cNvPr>
+          <p:cNvPicPr>
+            <a:picLocks noChangeAspect="1" noChangeArrowheads="1"/>
+          </p:cNvPicPr>
+          <p:nvPr/>
+        </p:nvPicPr>
+        <p:blipFill rotWithShape="1">
+          <a:blip r:embed="rId2">
+            <a:extLst>
+              <a:ext uri="{28A0092B-C50C-407E-A947-70E740481C1C}">
+                <a14:useLocalDpi xmlns:a14="http://schemas.microsoft.com/office/drawing/2010/main" val="0"/>
+              </a:ext>
+            </a:extLst>
+          </a:blip>
+          <a:srcRect l="8958" r="12083"/>
+          <a:stretch/>
+        </p:blipFill>
+        <p:spPr bwMode="auto">
+          <a:xfrm>
+            <a:off x="276225" y="2359453"/>
+            <a:ext cx="3238500" cy="3076148"/>
+          </a:xfrm>
+          <a:prstGeom prst="rect">
+            <a:avLst/>
+          </a:prstGeom>
+          <a:noFill/>
+          <a:extLst>
+            <a:ext uri="{909E8E84-426E-40DD-AFC4-6F175D3DCCD1}">
+              <a14:hiddenFill xmlns:a14="http://schemas.microsoft.com/office/drawing/2010/main">
+                <a:solidFill>
+                  <a:srgbClr val="FFFFFF"/>
+                </a:solidFill>
+              </a14:hiddenFill>
+            </a:ext>
+          </a:extLst>
+        </p:spPr>
+      </p:pic>
+      <p:pic>
+        <p:nvPicPr>
+          <p:cNvPr id="5124" name="Picture 4" descr="Harpacticoid Copepod">
+            <a:extLst>
+              <a:ext uri="{FF2B5EF4-FFF2-40B4-BE49-F238E27FC236}">
+                <a16:creationId xmlns:a16="http://schemas.microsoft.com/office/drawing/2014/main" id="{748F2D24-99B2-780A-591B-701C527E925D}"/>
+              </a:ext>
+            </a:extLst>
+          </p:cNvPr>
+          <p:cNvPicPr>
+            <a:picLocks noChangeAspect="1" noChangeArrowheads="1"/>
+          </p:cNvPicPr>
+          <p:nvPr/>
+        </p:nvPicPr>
+        <p:blipFill>
+          <a:blip r:embed="rId3">
+            <a:extLst>
+              <a:ext uri="{28A0092B-C50C-407E-A947-70E740481C1C}">
+                <a14:useLocalDpi xmlns:a14="http://schemas.microsoft.com/office/drawing/2010/main" val="0"/>
+              </a:ext>
+            </a:extLst>
+          </a:blip>
+          <a:srcRect/>
+          <a:stretch>
+            <a:fillRect/>
+          </a:stretch>
+        </p:blipFill>
+        <p:spPr bwMode="auto">
+          <a:xfrm rot="17541249">
+            <a:off x="3172194" y="3014612"/>
+            <a:ext cx="3253523" cy="2324913"/>
+          </a:xfrm>
+          <a:prstGeom prst="rect">
+            <a:avLst/>
+          </a:prstGeom>
+          <a:noFill/>
+          <a:extLst>
+            <a:ext uri="{909E8E84-426E-40DD-AFC4-6F175D3DCCD1}">
+              <a14:hiddenFill xmlns:a14="http://schemas.microsoft.com/office/drawing/2010/main">
+                <a:solidFill>
+                  <a:srgbClr val="FFFFFF"/>
+                </a:solidFill>
+              </a14:hiddenFill>
+            </a:ext>
+          </a:extLst>
+        </p:spPr>
+      </p:pic>
+      <p:pic>
+        <p:nvPicPr>
+          <p:cNvPr id="5128" name="Picture 8" descr="OITHONA SIMILIS (COPEPODA: CYCLOPOIDA) - A COSMOPOLITAN SPECIES?">
+            <a:extLst>
+              <a:ext uri="{FF2B5EF4-FFF2-40B4-BE49-F238E27FC236}">
+                <a16:creationId xmlns:a16="http://schemas.microsoft.com/office/drawing/2014/main" id="{242C968E-B88F-8DE0-00FD-25A2C2C9DA87}"/>
+              </a:ext>
+            </a:extLst>
+          </p:cNvPr>
+          <p:cNvPicPr>
+            <a:picLocks noChangeAspect="1" noChangeArrowheads="1"/>
+          </p:cNvPicPr>
+          <p:nvPr/>
+        </p:nvPicPr>
+        <p:blipFill>
+          <a:blip r:embed="rId4">
+            <a:extLst>
+              <a:ext uri="{BEBA8EAE-BF5A-486C-A8C5-ECC9F3942E4B}">
+                <a14:imgProps xmlns:a14="http://schemas.microsoft.com/office/drawing/2010/main">
+                  <a14:imgLayer r:embed="rId5">
+                    <a14:imgEffect>
+                      <a14:backgroundRemoval t="5155" b="96907" l="9653" r="89575">
+                        <a14:foregroundMark x1="67181" y1="32990" x2="85328" y2="49485"/>
+                        <a14:foregroundMark x1="85328" y1="49485" x2="88803" y2="55155"/>
+                        <a14:foregroundMark x1="61776" y1="29381" x2="47104" y2="11340"/>
+                        <a14:foregroundMark x1="47104" y1="11340" x2="38224" y2="5670"/>
+                        <a14:foregroundMark x1="25097" y1="82474" x2="13900" y2="81959"/>
+                        <a14:foregroundMark x1="33977" y1="85567" x2="34363" y2="96907"/>
+                        <a14:backgroundMark x1="60618" y1="56701" x2="66409" y2="87113"/>
+                        <a14:backgroundMark x1="66409" y1="87113" x2="66409" y2="87629"/>
+                        <a14:backgroundMark x1="52896" y1="63402" x2="40154" y2="81959"/>
+                        <a14:backgroundMark x1="40154" y1="81959" x2="67181" y2="96392"/>
+                        <a14:backgroundMark x1="67181" y1="96392" x2="73359" y2="96392"/>
+                      </a14:backgroundRemoval>
+                    </a14:imgEffect>
+                  </a14:imgLayer>
+                </a14:imgProps>
+              </a:ext>
+              <a:ext uri="{28A0092B-C50C-407E-A947-70E740481C1C}">
+                <a14:useLocalDpi xmlns:a14="http://schemas.microsoft.com/office/drawing/2010/main" val="0"/>
+              </a:ext>
+            </a:extLst>
+          </a:blip>
+          <a:srcRect/>
+          <a:stretch>
+            <a:fillRect/>
+          </a:stretch>
+        </p:blipFill>
+        <p:spPr bwMode="auto">
+          <a:xfrm rot="19260509">
+            <a:off x="5869572" y="2450278"/>
+            <a:ext cx="3405606" cy="2550918"/>
+          </a:xfrm>
+          <a:prstGeom prst="rect">
+            <a:avLst/>
+          </a:prstGeom>
+          <a:noFill/>
+          <a:extLst>
+            <a:ext uri="{909E8E84-426E-40DD-AFC4-6F175D3DCCD1}">
+              <a14:hiddenFill xmlns:a14="http://schemas.microsoft.com/office/drawing/2010/main">
+                <a:solidFill>
+                  <a:srgbClr val="FFFFFF"/>
+                </a:solidFill>
+              </a14:hiddenFill>
+            </a:ext>
+          </a:extLst>
+        </p:spPr>
+      </p:pic>
+      <p:pic>
+        <p:nvPicPr>
+          <p:cNvPr id="5132" name="Picture 12" descr="CalPhotos: Order Poecilostomatoida">
+            <a:extLst>
+              <a:ext uri="{FF2B5EF4-FFF2-40B4-BE49-F238E27FC236}">
+                <a16:creationId xmlns:a16="http://schemas.microsoft.com/office/drawing/2014/main" id="{BC0638FF-23DF-9579-6598-9FEF7C2EA1BB}"/>
+              </a:ext>
+            </a:extLst>
+          </p:cNvPr>
+          <p:cNvPicPr>
+            <a:picLocks noChangeAspect="1" noChangeArrowheads="1"/>
+          </p:cNvPicPr>
+          <p:nvPr/>
+        </p:nvPicPr>
+        <p:blipFill>
+          <a:blip r:embed="rId6">
+            <a:extLst>
+              <a:ext uri="{28A0092B-C50C-407E-A947-70E740481C1C}">
+                <a14:useLocalDpi xmlns:a14="http://schemas.microsoft.com/office/drawing/2010/main" val="0"/>
+              </a:ext>
+            </a:extLst>
+          </a:blip>
+          <a:srcRect/>
+          <a:stretch>
+            <a:fillRect/>
+          </a:stretch>
+        </p:blipFill>
+        <p:spPr bwMode="auto">
+          <a:xfrm rot="19700115">
+            <a:off x="9849796" y="2655754"/>
+            <a:ext cx="1747391" cy="2181083"/>
+          </a:xfrm>
+          <a:prstGeom prst="rect">
+            <a:avLst/>
+          </a:prstGeom>
+          <a:noFill/>
+          <a:extLst>
+            <a:ext uri="{909E8E84-426E-40DD-AFC4-6F175D3DCCD1}">
+              <a14:hiddenFill xmlns:a14="http://schemas.microsoft.com/office/drawing/2010/main">
+                <a:solidFill>
+                  <a:srgbClr val="FFFFFF"/>
+                </a:solidFill>
+              </a14:hiddenFill>
+            </a:ext>
+          </a:extLst>
+        </p:spPr>
+      </p:pic>
+      <p:sp>
+        <p:nvSpPr>
+          <p:cNvPr id="8" name="TextBox 7">
+            <a:extLst>
+              <a:ext uri="{FF2B5EF4-FFF2-40B4-BE49-F238E27FC236}">
+                <a16:creationId xmlns:a16="http://schemas.microsoft.com/office/drawing/2014/main" id="{EA74089E-13DB-49FB-29C4-D9056CF17BE3}"/>
+              </a:ext>
+            </a:extLst>
+          </p:cNvPr>
+          <p:cNvSpPr txBox="1"/>
+          <p:nvPr/>
+        </p:nvSpPr>
+        <p:spPr>
+          <a:xfrm>
+            <a:off x="2715347" y="6172018"/>
+            <a:ext cx="7554830" cy="646331"/>
+          </a:xfrm>
+          <a:prstGeom prst="rect">
+            <a:avLst/>
+          </a:prstGeom>
+          <a:noFill/>
+        </p:spPr>
+        <p:txBody>
+          <a:bodyPr wrap="square" rtlCol="0">
+            <a:spAutoFit/>
+          </a:bodyPr>
+          <a:lstStyle/>
+          <a:p>
+            <a:pPr algn="ctr"/>
+            <a:r>
+              <a:rPr lang="en-US" dirty="0"/>
+              <a:t>*note: apparently </a:t>
+            </a:r>
+            <a:r>
+              <a:rPr lang="en-US" dirty="0" err="1"/>
+              <a:t>poecilotomes</a:t>
+            </a:r>
+            <a:r>
+              <a:rPr lang="en-US" dirty="0"/>
+              <a:t> are now a suborder of cyclopoids, but we are ignoring that for the purposes of this lecture</a:t>
+            </a:r>
+          </a:p>
+        </p:txBody>
+      </p:sp>
+    </p:spTree>
+    <p:extLst>
+      <p:ext uri="{BB962C8B-B14F-4D97-AF65-F5344CB8AC3E}">
+        <p14:creationId xmlns:p14="http://schemas.microsoft.com/office/powerpoint/2010/main" val="2578597199"/>
+      </p:ext>
+    </p:extLst>
+  </p:cSld>
+  <p:clrMapOvr>
+    <a:masterClrMapping/>
+  </p:clrMapOvr>
+</p:sld>
+</file>
+
+<file path=ppt/slides/slide9.xml><?xml version="1.0" encoding="utf-8"?>
+<p:sld xmlns:a="http://schemas.openxmlformats.org/drawingml/2006/main" xmlns:r="http://schemas.openxmlformats.org/officeDocument/2006/relationships" xmlns:p="http://schemas.openxmlformats.org/presentationml/2006/main">
+  <p:cSld>
+    <p:spTree>
+      <p:nvGrpSpPr>
+        <p:cNvPr id="1" name=""/>
+        <p:cNvGrpSpPr/>
+        <p:nvPr/>
+      </p:nvGrpSpPr>
+      <p:grpSpPr>
+        <a:xfrm>
+          <a:off x="0" y="0"/>
+          <a:ext cx="0" cy="0"/>
+          <a:chOff x="0" y="0"/>
+          <a:chExt cx="0" cy="0"/>
+        </a:xfrm>
+      </p:grpSpPr>
+      <p:sp>
+        <p:nvSpPr>
+          <p:cNvPr id="2" name="Title 1">
+            <a:extLst>
+              <a:ext uri="{FF2B5EF4-FFF2-40B4-BE49-F238E27FC236}">
+                <a16:creationId xmlns:a16="http://schemas.microsoft.com/office/drawing/2014/main" id="{90C8D978-FD48-DCA3-7823-51CCDA0D4E92}"/>
+              </a:ext>
+            </a:extLst>
+          </p:cNvPr>
+          <p:cNvSpPr>
+            <a:spLocks noGrp="1"/>
+          </p:cNvSpPr>
+          <p:nvPr>
+            <p:ph type="ctrTitle"/>
+          </p:nvPr>
+        </p:nvSpPr>
+        <p:spPr/>
+        <p:txBody>
+          <a:bodyPr/>
+          <a:lstStyle/>
+          <a:p>
+            <a:r>
+              <a:rPr lang="en-US" dirty="0"/>
+              <a:t>Blackwater Manor </a:t>
+            </a:r>
+            <a:br>
+              <a:rPr lang="en-US" dirty="0"/>
+            </a:br>
+            <a:r>
+              <a:rPr lang="en-US" dirty="0"/>
+              <a:t>Coding Escape Room</a:t>
+            </a:r>
+          </a:p>
+        </p:txBody>
+      </p:sp>
+      <p:sp>
+        <p:nvSpPr>
+          <p:cNvPr id="3" name="Subtitle 2">
+            <a:extLst>
+              <a:ext uri="{FF2B5EF4-FFF2-40B4-BE49-F238E27FC236}">
+                <a16:creationId xmlns:a16="http://schemas.microsoft.com/office/drawing/2014/main" id="{4223BF77-ED66-A312-856C-58A0E22DD7A4}"/>
+              </a:ext>
+            </a:extLst>
+          </p:cNvPr>
+          <p:cNvSpPr>
+            <a:spLocks noGrp="1"/>
+          </p:cNvSpPr>
+          <p:nvPr>
+            <p:ph type="subTitle" idx="1"/>
+          </p:nvPr>
+        </p:nvSpPr>
+        <p:spPr>
+          <a:xfrm>
+            <a:off x="1524000" y="4559981"/>
+            <a:ext cx="9144000" cy="1655762"/>
+          </a:xfrm>
+        </p:spPr>
+        <p:txBody>
+          <a:bodyPr/>
+          <a:lstStyle/>
+          <a:p>
+            <a:endParaRPr lang="en-US" dirty="0"/>
+          </a:p>
+        </p:txBody>
+      </p:sp>
+    </p:spTree>
+    <p:extLst>
+      <p:ext uri="{BB962C8B-B14F-4D97-AF65-F5344CB8AC3E}">
+        <p14:creationId xmlns:p14="http://schemas.microsoft.com/office/powerpoint/2010/main" val="2678818095"/>
       </p:ext>
     </p:extLst>
   </p:cSld>

</xml_diff>